<commit_message>
Add Source of Truth to submission deck (Features, Technologies, Differentiation)
The 4-layer data lineage system (raw -> validated -> enriched -> stored,
per-incident, with its own audit tab) merged into main today via
PHASE-2-PREPARE-SOURCE-OF-TRUTH-FIXES but was missing from the deck.
Added as its own Features card, named explicitly in the Backend stack
on Technologies, and sharpened the Auditability row on Differentiation.
</commit_message>
<xml_diff>
--- a/docs/PPT/TerraGrid_AI_Builder_Cup_Submission_copilot_terragrid.pptx
+++ b/docs/PPT/TerraGrid_AI_Builder_Cup_Submission_copilot_terragrid.pptx
@@ -3352,7 +3352,7 @@
                 <a:ea typeface="Calibri" pitchFamily="34" charset="-122"/>
                 <a:cs typeface="Calibri" pitchFamily="34" charset="-120"/>
               </a:rPr>
-              <a:t>Decision-lineage &amp; validation logging</a:t>
+              <a:t>Source of Truth — 4-layer data lineage (raw -&gt; validated -&gt; enriched -&gt; stored)</a:t>
             </a:r>
             <a:endParaRPr lang="en-US" sz="1050" dirty="0"/>
           </a:p>
@@ -13374,7 +13374,7 @@
                           <a:ea typeface="Calibri" pitchFamily="34" charset="-122"/>
                           <a:cs typeface="Calibri" pitchFamily="34" charset="-120"/>
                         </a:rPr>
-                        <a:t>Every AI recommendation logged — source data and model output both</a:t>
+                        <a:t>Source of Truth — 4-layer data lineage (raw -&gt; validated -&gt; enriched -&gt; stored), plus every AI recommendation logged</a:t>
                       </a:r>
                       <a:endParaRPr lang="en-US" sz="1050" dirty="0">
                         <a:latin typeface="Calibri" charset="0"/>
@@ -16583,12 +16583,12 @@
         </p:nvSpPr>
         <p:spPr>
           <a:xfrm>
-            <a:off x="777240" y="1828800"/>
-            <a:ext cx="2556434" cy="1188720"/>
+            <a:off x="777240" y="1737360"/>
+            <a:ext cx="2556434" cy="896112"/>
           </a:xfrm>
           <a:prstGeom prst="roundRect">
             <a:avLst>
-              <a:gd name="adj" fmla="val 5385"/>
+              <a:gd name="adj" fmla="val 7143"/>
             </a:avLst>
           </a:prstGeom>
           <a:solidFill>
@@ -16610,8 +16610,8 @@
         </p:nvSpPr>
         <p:spPr>
           <a:xfrm>
-            <a:off x="914400" y="1965960"/>
-            <a:ext cx="274320" cy="274320"/>
+            <a:off x="896112" y="1856232"/>
+            <a:ext cx="237744" cy="237744"/>
           </a:xfrm>
           <a:prstGeom prst="ellipse">
             <a:avLst/>
@@ -16630,8 +16630,8 @@
         </p:nvSpPr>
         <p:spPr>
           <a:xfrm>
-            <a:off x="914400" y="2304288"/>
-            <a:ext cx="2282114" cy="274320"/>
+            <a:off x="896112" y="2139696"/>
+            <a:ext cx="2318690" cy="237744"/>
           </a:xfrm>
           <a:prstGeom prst="rect">
             <a:avLst/>
@@ -16647,14 +16647,14 @@
               <a:buNone/>
             </a:pPr>
             <a:r>
-              <a:rPr lang="en-US" sz="1100" b="1" dirty="0">
+              <a:rPr lang="en-US" sz="950" b="1" dirty="0">
                 <a:solidFill>
                   <a:srgbClr val="0F1B2D"/>
                 </a:solidFill>
               </a:rPr>
               <a:t>Multi-Source Intelligence</a:t>
             </a:r>
-            <a:endParaRPr lang="en-US" sz="1100" dirty="0"/>
+            <a:endParaRPr lang="en-US" sz="950" dirty="0"/>
           </a:p>
         </p:txBody>
       </p:sp>
@@ -16666,8 +16666,8 @@
         </p:nvSpPr>
         <p:spPr>
           <a:xfrm>
-            <a:off x="914400" y="2578608"/>
-            <a:ext cx="2282114" cy="384048"/>
+            <a:off x="896112" y="2377440"/>
+            <a:ext cx="2318690" cy="246888"/>
           </a:xfrm>
           <a:prstGeom prst="rect">
             <a:avLst/>
@@ -16683,14 +16683,14 @@
               <a:buNone/>
             </a:pPr>
             <a:r>
-              <a:rPr lang="en-US" sz="850" dirty="0">
+              <a:rPr lang="en-US" sz="750" dirty="0">
                 <a:solidFill>
                   <a:srgbClr val="6B7684"/>
                 </a:solidFill>
               </a:rPr>
               <a:t>6 live APIs auto-ingested — NASA EONET, USGS, NOAA, GDACS, OpenWeatherMap, OSM/Overpass</a:t>
             </a:r>
-            <a:endParaRPr lang="en-US" sz="850" dirty="0"/>
+            <a:endParaRPr lang="en-US" sz="750" dirty="0"/>
           </a:p>
         </p:txBody>
       </p:sp>
@@ -16702,12 +16702,12 @@
         </p:nvSpPr>
         <p:spPr>
           <a:xfrm>
-            <a:off x="3470834" y="1828800"/>
-            <a:ext cx="2556434" cy="1188720"/>
+            <a:off x="3470834" y="1737360"/>
+            <a:ext cx="2556434" cy="896112"/>
           </a:xfrm>
           <a:prstGeom prst="roundRect">
             <a:avLst>
-              <a:gd name="adj" fmla="val 5385"/>
+              <a:gd name="adj" fmla="val 7143"/>
             </a:avLst>
           </a:prstGeom>
           <a:solidFill>
@@ -16729,8 +16729,8 @@
         </p:nvSpPr>
         <p:spPr>
           <a:xfrm>
-            <a:off x="3607994" y="1965960"/>
-            <a:ext cx="274320" cy="274320"/>
+            <a:off x="3589706" y="1856232"/>
+            <a:ext cx="237744" cy="237744"/>
           </a:xfrm>
           <a:prstGeom prst="ellipse">
             <a:avLst/>
@@ -16749,8 +16749,8 @@
         </p:nvSpPr>
         <p:spPr>
           <a:xfrm>
-            <a:off x="3607994" y="2304288"/>
-            <a:ext cx="2282114" cy="274320"/>
+            <a:off x="3589706" y="2139696"/>
+            <a:ext cx="2318690" cy="237744"/>
           </a:xfrm>
           <a:prstGeom prst="rect">
             <a:avLst/>
@@ -16766,14 +16766,14 @@
               <a:buNone/>
             </a:pPr>
             <a:r>
-              <a:rPr lang="en-US" sz="1100" b="1" dirty="0">
+              <a:rPr lang="en-US" sz="950" b="1" dirty="0">
                 <a:solidFill>
                   <a:srgbClr val="0F1B2D"/>
                 </a:solidFill>
               </a:rPr>
               <a:t>AI Decision Support</a:t>
             </a:r>
-            <a:endParaRPr lang="en-US" sz="1100" dirty="0"/>
+            <a:endParaRPr lang="en-US" sz="950" dirty="0"/>
           </a:p>
         </p:txBody>
       </p:sp>
@@ -16785,8 +16785,8 @@
         </p:nvSpPr>
         <p:spPr>
           <a:xfrm>
-            <a:off x="3607994" y="2578608"/>
-            <a:ext cx="2282114" cy="384048"/>
+            <a:off x="3589706" y="2377440"/>
+            <a:ext cx="2318690" cy="246888"/>
           </a:xfrm>
           <a:prstGeom prst="rect">
             <a:avLst/>
@@ -16802,14 +16802,14 @@
               <a:buNone/>
             </a:pPr>
             <a:r>
-              <a:rPr lang="en-US" sz="850" dirty="0">
+              <a:rPr lang="en-US" sz="750" dirty="0">
                 <a:solidFill>
                   <a:srgbClr val="6B7684"/>
                 </a:solidFill>
               </a:rPr>
               <a:t>Gemini 2.5 Flash generates action plans with confidence scoring</a:t>
             </a:r>
-            <a:endParaRPr lang="en-US" sz="850" dirty="0"/>
+            <a:endParaRPr lang="en-US" sz="750" dirty="0"/>
           </a:p>
         </p:txBody>
       </p:sp>
@@ -16821,12 +16821,12 @@
         </p:nvSpPr>
         <p:spPr>
           <a:xfrm>
-            <a:off x="6164428" y="1828800"/>
-            <a:ext cx="2556434" cy="1188720"/>
+            <a:off x="6164428" y="1737360"/>
+            <a:ext cx="2556434" cy="896112"/>
           </a:xfrm>
           <a:prstGeom prst="roundRect">
             <a:avLst>
-              <a:gd name="adj" fmla="val 5385"/>
+              <a:gd name="adj" fmla="val 7143"/>
             </a:avLst>
           </a:prstGeom>
           <a:solidFill>
@@ -16848,8 +16848,8 @@
         </p:nvSpPr>
         <p:spPr>
           <a:xfrm>
-            <a:off x="6301588" y="1965960"/>
-            <a:ext cx="274320" cy="274320"/>
+            <a:off x="6283300" y="1856232"/>
+            <a:ext cx="237744" cy="237744"/>
           </a:xfrm>
           <a:prstGeom prst="ellipse">
             <a:avLst/>
@@ -16868,8 +16868,8 @@
         </p:nvSpPr>
         <p:spPr>
           <a:xfrm>
-            <a:off x="6301588" y="2304288"/>
-            <a:ext cx="2282114" cy="274320"/>
+            <a:off x="6283300" y="2139696"/>
+            <a:ext cx="2318690" cy="237744"/>
           </a:xfrm>
           <a:prstGeom prst="rect">
             <a:avLst/>
@@ -16885,14 +16885,14 @@
               <a:buNone/>
             </a:pPr>
             <a:r>
-              <a:rPr lang="en-US" sz="1100" b="1" dirty="0">
+              <a:rPr lang="en-US" sz="950" b="1" dirty="0">
                 <a:solidFill>
                   <a:srgbClr val="0F1B2D"/>
                 </a:solidFill>
               </a:rPr>
               <a:t>Satellite Verification</a:t>
             </a:r>
-            <a:endParaRPr lang="en-US" sz="1100" dirty="0"/>
+            <a:endParaRPr lang="en-US" sz="950" dirty="0"/>
           </a:p>
         </p:txBody>
       </p:sp>
@@ -16904,8 +16904,8 @@
         </p:nvSpPr>
         <p:spPr>
           <a:xfrm>
-            <a:off x="6301588" y="2578608"/>
-            <a:ext cx="2282114" cy="384048"/>
+            <a:off x="6283300" y="2377440"/>
+            <a:ext cx="2318690" cy="246888"/>
           </a:xfrm>
           <a:prstGeom prst="rect">
             <a:avLst/>
@@ -16921,14 +16921,14 @@
               <a:buNone/>
             </a:pPr>
             <a:r>
-              <a:rPr lang="en-US" sz="850" dirty="0">
+              <a:rPr lang="en-US" sz="750" dirty="0">
                 <a:solidFill>
                   <a:srgbClr val="6B7684"/>
                 </a:solidFill>
               </a:rPr>
               <a:t>Sentinel-1 SAR cross-validation via Google Earth Engine</a:t>
             </a:r>
-            <a:endParaRPr lang="en-US" sz="850" dirty="0"/>
+            <a:endParaRPr lang="en-US" sz="750" dirty="0"/>
           </a:p>
         </p:txBody>
       </p:sp>
@@ -16940,12 +16940,12 @@
         </p:nvSpPr>
         <p:spPr>
           <a:xfrm>
-            <a:off x="8858021" y="1828800"/>
-            <a:ext cx="2556434" cy="1188720"/>
+            <a:off x="8858021" y="1737360"/>
+            <a:ext cx="2556434" cy="896112"/>
           </a:xfrm>
           <a:prstGeom prst="roundRect">
             <a:avLst>
-              <a:gd name="adj" fmla="val 5385"/>
+              <a:gd name="adj" fmla="val 7143"/>
             </a:avLst>
           </a:prstGeom>
           <a:solidFill>
@@ -16967,8 +16967,8 @@
         </p:nvSpPr>
         <p:spPr>
           <a:xfrm>
-            <a:off x="8995181" y="1965960"/>
-            <a:ext cx="274320" cy="274320"/>
+            <a:off x="8976893" y="1856232"/>
+            <a:ext cx="237744" cy="237744"/>
           </a:xfrm>
           <a:prstGeom prst="ellipse">
             <a:avLst/>
@@ -16987,8 +16987,8 @@
         </p:nvSpPr>
         <p:spPr>
           <a:xfrm>
-            <a:off x="8995181" y="2304288"/>
-            <a:ext cx="2282114" cy="274320"/>
+            <a:off x="8976893" y="2139696"/>
+            <a:ext cx="2318690" cy="237744"/>
           </a:xfrm>
           <a:prstGeom prst="rect">
             <a:avLst/>
@@ -17004,14 +17004,14 @@
               <a:buNone/>
             </a:pPr>
             <a:r>
-              <a:rPr lang="en-US" sz="1100" b="1" dirty="0">
+              <a:rPr lang="en-US" sz="950" b="1" dirty="0">
                 <a:solidFill>
                   <a:srgbClr val="0F1B2D"/>
                 </a:solidFill>
               </a:rPr>
               <a:t>Decision Lineage</a:t>
             </a:r>
-            <a:endParaRPr lang="en-US" sz="1100" dirty="0"/>
+            <a:endParaRPr lang="en-US" sz="950" dirty="0"/>
           </a:p>
         </p:txBody>
       </p:sp>
@@ -17023,8 +17023,8 @@
         </p:nvSpPr>
         <p:spPr>
           <a:xfrm>
-            <a:off x="8995181" y="2578608"/>
-            <a:ext cx="2282114" cy="384048"/>
+            <a:off x="8976893" y="2377440"/>
+            <a:ext cx="2318690" cy="246888"/>
           </a:xfrm>
           <a:prstGeom prst="rect">
             <a:avLst/>
@@ -17040,14 +17040,14 @@
               <a:buNone/>
             </a:pPr>
             <a:r>
-              <a:rPr lang="en-US" sz="850" dirty="0">
+              <a:rPr lang="en-US" sz="750" dirty="0">
                 <a:solidFill>
                   <a:srgbClr val="6B7684"/>
                 </a:solidFill>
               </a:rPr>
               <a:t>Every AI output logged as a timestamped, auditable record</a:t>
             </a:r>
-            <a:endParaRPr lang="en-US" sz="850" dirty="0"/>
+            <a:endParaRPr lang="en-US" sz="750" dirty="0"/>
           </a:p>
         </p:txBody>
       </p:sp>
@@ -17059,12 +17059,12 @@
         </p:nvSpPr>
         <p:spPr>
           <a:xfrm>
-            <a:off x="777240" y="3154680"/>
-            <a:ext cx="2556434" cy="1188720"/>
+            <a:off x="777240" y="2724912"/>
+            <a:ext cx="2556434" cy="896112"/>
           </a:xfrm>
           <a:prstGeom prst="roundRect">
             <a:avLst>
-              <a:gd name="adj" fmla="val 5385"/>
+              <a:gd name="adj" fmla="val 7143"/>
             </a:avLst>
           </a:prstGeom>
           <a:solidFill>
@@ -17086,14 +17086,14 @@
         </p:nvSpPr>
         <p:spPr>
           <a:xfrm>
-            <a:off x="914400" y="3291840"/>
-            <a:ext cx="274320" cy="274320"/>
+            <a:off x="896112" y="2843784"/>
+            <a:ext cx="237744" cy="237744"/>
           </a:xfrm>
           <a:prstGeom prst="ellipse">
             <a:avLst/>
           </a:prstGeom>
           <a:solidFill>
-            <a:srgbClr val="E8722C"/>
+            <a:srgbClr val="0E7490"/>
           </a:solidFill>
           <a:ln/>
         </p:spPr>
@@ -17106,8 +17106,8 @@
         </p:nvSpPr>
         <p:spPr>
           <a:xfrm>
-            <a:off x="914400" y="3630168"/>
-            <a:ext cx="2282114" cy="274320"/>
+            <a:off x="896112" y="3127248"/>
+            <a:ext cx="2318690" cy="237744"/>
           </a:xfrm>
           <a:prstGeom prst="rect">
             <a:avLst/>
@@ -17123,14 +17123,14 @@
               <a:buNone/>
             </a:pPr>
             <a:r>
-              <a:rPr lang="en-US" sz="1100" b="1" dirty="0">
+              <a:rPr lang="en-US" sz="950" b="1" dirty="0">
                 <a:solidFill>
                   <a:srgbClr val="0F1B2D"/>
                 </a:solidFill>
               </a:rPr>
-              <a:t>7-Day Risk Forecasting</a:t>
-            </a:r>
-            <a:endParaRPr lang="en-US" sz="1100" dirty="0"/>
+              <a:t>Source Of Truth</a:t>
+            </a:r>
+            <a:endParaRPr lang="en-US" sz="950" dirty="0"/>
           </a:p>
         </p:txBody>
       </p:sp>
@@ -17142,8 +17142,8 @@
         </p:nvSpPr>
         <p:spPr>
           <a:xfrm>
-            <a:off x="914400" y="3904488"/>
-            <a:ext cx="2282114" cy="384048"/>
+            <a:off x="896112" y="3364992"/>
+            <a:ext cx="2318690" cy="246888"/>
           </a:xfrm>
           <a:prstGeom prst="rect">
             <a:avLst/>
@@ -17159,14 +17159,14 @@
               <a:buNone/>
             </a:pPr>
             <a:r>
-              <a:rPr lang="en-US" sz="850" dirty="0">
+              <a:rPr lang="en-US" sz="750" dirty="0">
                 <a:solidFill>
                   <a:srgbClr val="6B7684"/>
                 </a:solidFill>
               </a:rPr>
-              <a:t>Rolling forecasts across 8 cities, updated continuously</a:t>
-            </a:r>
-            <a:endParaRPr lang="en-US" sz="850" dirty="0"/>
+              <a:t>4-layer data lineage — raw -&gt; validated -&gt; enriched -&gt; stored — tracked per incident, with its own audit tab in the UI</a:t>
+            </a:r>
+            <a:endParaRPr lang="en-US" sz="750" dirty="0"/>
           </a:p>
         </p:txBody>
       </p:sp>
@@ -17178,12 +17178,12 @@
         </p:nvSpPr>
         <p:spPr>
           <a:xfrm>
-            <a:off x="3470834" y="3154680"/>
-            <a:ext cx="2556434" cy="1188720"/>
+            <a:off x="3470834" y="2724912"/>
+            <a:ext cx="2556434" cy="896112"/>
           </a:xfrm>
           <a:prstGeom prst="roundRect">
             <a:avLst>
-              <a:gd name="adj" fmla="val 5385"/>
+              <a:gd name="adj" fmla="val 7143"/>
             </a:avLst>
           </a:prstGeom>
           <a:solidFill>
@@ -17205,8 +17205,8 @@
         </p:nvSpPr>
         <p:spPr>
           <a:xfrm>
-            <a:off x="3607994" y="3291840"/>
-            <a:ext cx="274320" cy="274320"/>
+            <a:off x="3589706" y="2843784"/>
+            <a:ext cx="237744" cy="237744"/>
           </a:xfrm>
           <a:prstGeom prst="ellipse">
             <a:avLst/>
@@ -17225,8 +17225,8 @@
         </p:nvSpPr>
         <p:spPr>
           <a:xfrm>
-            <a:off x="3607994" y="3630168"/>
-            <a:ext cx="2282114" cy="274320"/>
+            <a:off x="3589706" y="3127248"/>
+            <a:ext cx="2318690" cy="237744"/>
           </a:xfrm>
           <a:prstGeom prst="rect">
             <a:avLst/>
@@ -17242,14 +17242,14 @@
               <a:buNone/>
             </a:pPr>
             <a:r>
-              <a:rPr lang="en-US" sz="1100" b="1" dirty="0">
+              <a:rPr lang="en-US" sz="950" b="1" dirty="0">
                 <a:solidFill>
                   <a:srgbClr val="0F1B2D"/>
                 </a:solidFill>
               </a:rPr>
-              <a:t>Risk-Escalation Timeline</a:t>
-            </a:r>
-            <a:endParaRPr lang="en-US" sz="1100" dirty="0"/>
+              <a:t>7-Day Risk Forecasting</a:t>
+            </a:r>
+            <a:endParaRPr lang="en-US" sz="950" dirty="0"/>
           </a:p>
         </p:txBody>
       </p:sp>
@@ -17261,8 +17261,8 @@
         </p:nvSpPr>
         <p:spPr>
           <a:xfrm>
-            <a:off x="3607994" y="3904488"/>
-            <a:ext cx="2282114" cy="384048"/>
+            <a:off x="3589706" y="3364992"/>
+            <a:ext cx="2318690" cy="246888"/>
           </a:xfrm>
           <a:prstGeom prst="rect">
             <a:avLst/>
@@ -17278,14 +17278,14 @@
               <a:buNone/>
             </a:pPr>
             <a:r>
-              <a:rPr lang="en-US" sz="850" dirty="0">
+              <a:rPr lang="en-US" sz="750" dirty="0">
                 <a:solidFill>
                   <a:srgbClr val="6B7684"/>
                 </a:solidFill>
               </a:rPr>
-              <a:t>AI-generated, phase-by-phase escalation outlook</a:t>
-            </a:r>
-            <a:endParaRPr lang="en-US" sz="850" dirty="0"/>
+              <a:t>Rolling forecasts across 8 cities, updated continuously</a:t>
+            </a:r>
+            <a:endParaRPr lang="en-US" sz="750" dirty="0"/>
           </a:p>
         </p:txBody>
       </p:sp>
@@ -17297,12 +17297,12 @@
         </p:nvSpPr>
         <p:spPr>
           <a:xfrm>
-            <a:off x="6164428" y="3154680"/>
-            <a:ext cx="2556434" cy="1188720"/>
+            <a:off x="6164428" y="2724912"/>
+            <a:ext cx="2556434" cy="896112"/>
           </a:xfrm>
           <a:prstGeom prst="roundRect">
             <a:avLst>
-              <a:gd name="adj" fmla="val 5385"/>
+              <a:gd name="adj" fmla="val 7143"/>
             </a:avLst>
           </a:prstGeom>
           <a:solidFill>
@@ -17324,8 +17324,8 @@
         </p:nvSpPr>
         <p:spPr>
           <a:xfrm>
-            <a:off x="6301588" y="3291840"/>
-            <a:ext cx="274320" cy="274320"/>
+            <a:off x="6283300" y="2843784"/>
+            <a:ext cx="237744" cy="237744"/>
           </a:xfrm>
           <a:prstGeom prst="ellipse">
             <a:avLst/>
@@ -17344,8 +17344,8 @@
         </p:nvSpPr>
         <p:spPr>
           <a:xfrm>
-            <a:off x="6301588" y="3630168"/>
-            <a:ext cx="2282114" cy="274320"/>
+            <a:off x="6283300" y="3127248"/>
+            <a:ext cx="2318690" cy="237744"/>
           </a:xfrm>
           <a:prstGeom prst="rect">
             <a:avLst/>
@@ -17361,14 +17361,14 @@
               <a:buNone/>
             </a:pPr>
             <a:r>
-              <a:rPr lang="en-US" sz="1100" b="1" dirty="0">
+              <a:rPr lang="en-US" sz="950" b="1" dirty="0">
                 <a:solidFill>
                   <a:srgbClr val="0F1B2D"/>
                 </a:solidFill>
               </a:rPr>
-              <a:t>Preparedness Checklists</a:t>
-            </a:r>
-            <a:endParaRPr lang="en-US" sz="1100" dirty="0"/>
+              <a:t>Risk-Escalation Timeline</a:t>
+            </a:r>
+            <a:endParaRPr lang="en-US" sz="950" dirty="0"/>
           </a:p>
         </p:txBody>
       </p:sp>
@@ -17380,8 +17380,8 @@
         </p:nvSpPr>
         <p:spPr>
           <a:xfrm>
-            <a:off x="6301588" y="3904488"/>
-            <a:ext cx="2282114" cy="384048"/>
+            <a:off x="6283300" y="3364992"/>
+            <a:ext cx="2318690" cy="246888"/>
           </a:xfrm>
           <a:prstGeom prst="rect">
             <a:avLst/>
@@ -17397,14 +17397,14 @@
               <a:buNone/>
             </a:pPr>
             <a:r>
-              <a:rPr lang="en-US" sz="850" dirty="0">
+              <a:rPr lang="en-US" sz="750" dirty="0">
                 <a:solidFill>
                   <a:srgbClr val="6B7684"/>
                 </a:solidFill>
               </a:rPr>
-              <a:t>Auto-generated per agency, ready before an event escalates</a:t>
-            </a:r>
-            <a:endParaRPr lang="en-US" sz="850" dirty="0"/>
+              <a:t>AI-generated, phase-by-phase escalation outlook</a:t>
+            </a:r>
+            <a:endParaRPr lang="en-US" sz="750" dirty="0"/>
           </a:p>
         </p:txBody>
       </p:sp>
@@ -17416,12 +17416,12 @@
         </p:nvSpPr>
         <p:spPr>
           <a:xfrm>
-            <a:off x="8858021" y="3154680"/>
-            <a:ext cx="2556434" cy="1188720"/>
+            <a:off x="8858021" y="2724912"/>
+            <a:ext cx="2556434" cy="896112"/>
           </a:xfrm>
           <a:prstGeom prst="roundRect">
             <a:avLst>
-              <a:gd name="adj" fmla="val 5385"/>
+              <a:gd name="adj" fmla="val 7143"/>
             </a:avLst>
           </a:prstGeom>
           <a:solidFill>
@@ -17443,8 +17443,8 @@
         </p:nvSpPr>
         <p:spPr>
           <a:xfrm>
-            <a:off x="8995181" y="3291840"/>
-            <a:ext cx="274320" cy="274320"/>
+            <a:off x="8976893" y="2843784"/>
+            <a:ext cx="237744" cy="237744"/>
           </a:xfrm>
           <a:prstGeom prst="ellipse">
             <a:avLst/>
@@ -17463,8 +17463,8 @@
         </p:nvSpPr>
         <p:spPr>
           <a:xfrm>
-            <a:off x="8995181" y="3630168"/>
-            <a:ext cx="2282114" cy="274320"/>
+            <a:off x="8976893" y="3127248"/>
+            <a:ext cx="2318690" cy="237744"/>
           </a:xfrm>
           <a:prstGeom prst="rect">
             <a:avLst/>
@@ -17480,14 +17480,14 @@
               <a:buNone/>
             </a:pPr>
             <a:r>
-              <a:rPr lang="en-US" sz="1100" b="1" dirty="0">
+              <a:rPr lang="en-US" sz="950" b="1" dirty="0">
                 <a:solidFill>
                   <a:srgbClr val="0F1B2D"/>
                 </a:solidFill>
               </a:rPr>
-              <a:t>Agency Alert Drafting</a:t>
-            </a:r>
-            <a:endParaRPr lang="en-US" sz="1100" dirty="0"/>
+              <a:t>Preparedness Checklists</a:t>
+            </a:r>
+            <a:endParaRPr lang="en-US" sz="950" dirty="0"/>
           </a:p>
         </p:txBody>
       </p:sp>
@@ -17499,8 +17499,8 @@
         </p:nvSpPr>
         <p:spPr>
           <a:xfrm>
-            <a:off x="8995181" y="3904488"/>
-            <a:ext cx="2282114" cy="384048"/>
+            <a:off x="8976893" y="3364992"/>
+            <a:ext cx="2318690" cy="246888"/>
           </a:xfrm>
           <a:prstGeom prst="rect">
             <a:avLst/>
@@ -17516,14 +17516,14 @@
               <a:buNone/>
             </a:pPr>
             <a:r>
-              <a:rPr lang="en-US" sz="850" dirty="0">
+              <a:rPr lang="en-US" sz="750" dirty="0">
                 <a:solidFill>
                   <a:srgbClr val="6B7684"/>
                 </a:solidFill>
               </a:rPr>
-              <a:t>Automated first-draft alerts, ready for review and send</a:t>
-            </a:r>
-            <a:endParaRPr lang="en-US" sz="850" dirty="0"/>
+              <a:t>Auto-generated per agency, ready before an event escalates</a:t>
+            </a:r>
+            <a:endParaRPr lang="en-US" sz="750" dirty="0"/>
           </a:p>
         </p:txBody>
       </p:sp>
@@ -17535,12 +17535,12 @@
         </p:nvSpPr>
         <p:spPr>
           <a:xfrm>
-            <a:off x="777240" y="4480560"/>
-            <a:ext cx="2556434" cy="1188720"/>
+            <a:off x="777240" y="3712464"/>
+            <a:ext cx="2556434" cy="896112"/>
           </a:xfrm>
           <a:prstGeom prst="roundRect">
             <a:avLst>
-              <a:gd name="adj" fmla="val 5385"/>
+              <a:gd name="adj" fmla="val 7143"/>
             </a:avLst>
           </a:prstGeom>
           <a:solidFill>
@@ -17562,14 +17562,14 @@
         </p:nvSpPr>
         <p:spPr>
           <a:xfrm>
-            <a:off x="914400" y="4617720"/>
-            <a:ext cx="274320" cy="274320"/>
+            <a:off x="896112" y="3831336"/>
+            <a:ext cx="237744" cy="237744"/>
           </a:xfrm>
           <a:prstGeom prst="ellipse">
             <a:avLst/>
           </a:prstGeom>
           <a:solidFill>
-            <a:srgbClr val="5B6472"/>
+            <a:srgbClr val="E8722C"/>
           </a:solidFill>
           <a:ln/>
         </p:spPr>
@@ -17582,8 +17582,8 @@
         </p:nvSpPr>
         <p:spPr>
           <a:xfrm>
-            <a:off x="914400" y="4956048"/>
-            <a:ext cx="2282114" cy="274320"/>
+            <a:off x="896112" y="4114800"/>
+            <a:ext cx="2318690" cy="237744"/>
           </a:xfrm>
           <a:prstGeom prst="rect">
             <a:avLst/>
@@ -17599,14 +17599,14 @@
               <a:buNone/>
             </a:pPr>
             <a:r>
-              <a:rPr lang="en-US" sz="1100" b="1" dirty="0">
+              <a:rPr lang="en-US" sz="950" b="1" dirty="0">
                 <a:solidFill>
                   <a:srgbClr val="0F1B2D"/>
                 </a:solidFill>
               </a:rPr>
-              <a:t>Live Incident Dashboard</a:t>
-            </a:r>
-            <a:endParaRPr lang="en-US" sz="1100" dirty="0"/>
+              <a:t>Agency Alert Drafting</a:t>
+            </a:r>
+            <a:endParaRPr lang="en-US" sz="950" dirty="0"/>
           </a:p>
         </p:txBody>
       </p:sp>
@@ -17618,8 +17618,8 @@
         </p:nvSpPr>
         <p:spPr>
           <a:xfrm>
-            <a:off x="914400" y="5230368"/>
-            <a:ext cx="2282114" cy="384048"/>
+            <a:off x="896112" y="4352544"/>
+            <a:ext cx="2318690" cy="246888"/>
           </a:xfrm>
           <a:prstGeom prst="rect">
             <a:avLst/>
@@ -17635,14 +17635,14 @@
               <a:buNone/>
             </a:pPr>
             <a:r>
-              <a:rPr lang="en-US" sz="850" dirty="0">
+              <a:rPr lang="en-US" sz="750" dirty="0">
                 <a:solidFill>
                   <a:srgbClr val="6B7684"/>
                 </a:solidFill>
               </a:rPr>
-              <a:t>Multi-hazard map + detail panel, WebSocket-live</a:t>
-            </a:r>
-            <a:endParaRPr lang="en-US" sz="850" dirty="0"/>
+              <a:t>Automated first-draft alerts, ready for review and send</a:t>
+            </a:r>
+            <a:endParaRPr lang="en-US" sz="750" dirty="0"/>
           </a:p>
         </p:txBody>
       </p:sp>
@@ -17654,12 +17654,12 @@
         </p:nvSpPr>
         <p:spPr>
           <a:xfrm>
-            <a:off x="3470834" y="4480560"/>
-            <a:ext cx="2556434" cy="1188720"/>
+            <a:off x="3470834" y="3712464"/>
+            <a:ext cx="2556434" cy="896112"/>
           </a:xfrm>
           <a:prstGeom prst="roundRect">
             <a:avLst>
-              <a:gd name="adj" fmla="val 5385"/>
+              <a:gd name="adj" fmla="val 7143"/>
             </a:avLst>
           </a:prstGeom>
           <a:solidFill>
@@ -17681,8 +17681,8 @@
         </p:nvSpPr>
         <p:spPr>
           <a:xfrm>
-            <a:off x="3607994" y="4617720"/>
-            <a:ext cx="274320" cy="274320"/>
+            <a:off x="3589706" y="3831336"/>
+            <a:ext cx="237744" cy="237744"/>
           </a:xfrm>
           <a:prstGeom prst="ellipse">
             <a:avLst/>
@@ -17701,8 +17701,8 @@
         </p:nvSpPr>
         <p:spPr>
           <a:xfrm>
-            <a:off x="3607994" y="4956048"/>
-            <a:ext cx="2282114" cy="274320"/>
+            <a:off x="3589706" y="4114800"/>
+            <a:ext cx="2318690" cy="237744"/>
           </a:xfrm>
           <a:prstGeom prst="rect">
             <a:avLst/>
@@ -17718,14 +17718,14 @@
               <a:buNone/>
             </a:pPr>
             <a:r>
-              <a:rPr lang="en-US" sz="1100" b="1" dirty="0">
+              <a:rPr lang="en-US" sz="950" b="1" dirty="0">
                 <a:solidFill>
                   <a:srgbClr val="0F1B2D"/>
                 </a:solidFill>
               </a:rPr>
-              <a:t>Evacuation Routing</a:t>
-            </a:r>
-            <a:endParaRPr lang="en-US" sz="1100" dirty="0"/>
+              <a:t>Live Incident Dashboard</a:t>
+            </a:r>
+            <a:endParaRPr lang="en-US" sz="950" dirty="0"/>
           </a:p>
         </p:txBody>
       </p:sp>
@@ -17737,8 +17737,8 @@
         </p:nvSpPr>
         <p:spPr>
           <a:xfrm>
-            <a:off x="3607994" y="5230368"/>
-            <a:ext cx="2282114" cy="384048"/>
+            <a:off x="3589706" y="4352544"/>
+            <a:ext cx="2318690" cy="246888"/>
           </a:xfrm>
           <a:prstGeom prst="rect">
             <a:avLst/>
@@ -17754,14 +17754,14 @@
               <a:buNone/>
             </a:pPr>
             <a:r>
-              <a:rPr lang="en-US" sz="850" dirty="0">
+              <a:rPr lang="en-US" sz="750" dirty="0">
                 <a:solidFill>
                   <a:srgbClr val="6B7684"/>
                 </a:solidFill>
               </a:rPr>
-              <a:t>OSRM road-network routing with automatic geodesic fallback</a:t>
-            </a:r>
-            <a:endParaRPr lang="en-US" sz="850" dirty="0"/>
+              <a:t>Multi-hazard map + detail panel, WebSocket-live</a:t>
+            </a:r>
+            <a:endParaRPr lang="en-US" sz="750" dirty="0"/>
           </a:p>
         </p:txBody>
       </p:sp>
@@ -17773,12 +17773,12 @@
         </p:nvSpPr>
         <p:spPr>
           <a:xfrm>
-            <a:off x="6164428" y="4480560"/>
-            <a:ext cx="2556434" cy="1188720"/>
+            <a:off x="6164428" y="3712464"/>
+            <a:ext cx="2556434" cy="896112"/>
           </a:xfrm>
           <a:prstGeom prst="roundRect">
             <a:avLst>
-              <a:gd name="adj" fmla="val 5385"/>
+              <a:gd name="adj" fmla="val 7143"/>
             </a:avLst>
           </a:prstGeom>
           <a:solidFill>
@@ -17800,8 +17800,8 @@
         </p:nvSpPr>
         <p:spPr>
           <a:xfrm>
-            <a:off x="6301588" y="4617720"/>
-            <a:ext cx="274320" cy="274320"/>
+            <a:off x="6283300" y="3831336"/>
+            <a:ext cx="237744" cy="237744"/>
           </a:xfrm>
           <a:prstGeom prst="ellipse">
             <a:avLst/>
@@ -17820,8 +17820,8 @@
         </p:nvSpPr>
         <p:spPr>
           <a:xfrm>
-            <a:off x="6301588" y="4956048"/>
-            <a:ext cx="2282114" cy="274320"/>
+            <a:off x="6283300" y="4114800"/>
+            <a:ext cx="2318690" cy="237744"/>
           </a:xfrm>
           <a:prstGeom prst="rect">
             <a:avLst/>
@@ -17837,14 +17837,14 @@
               <a:buNone/>
             </a:pPr>
             <a:r>
-              <a:rPr lang="en-US" sz="1100" b="1" dirty="0">
+              <a:rPr lang="en-US" sz="950" b="1" dirty="0">
                 <a:solidFill>
                   <a:srgbClr val="0F1B2D"/>
                 </a:solidFill>
               </a:rPr>
-              <a:t>Audience-Tailored Alerts</a:t>
-            </a:r>
-            <a:endParaRPr lang="en-US" sz="1100" dirty="0"/>
+              <a:t>Evacuation Routing</a:t>
+            </a:r>
+            <a:endParaRPr lang="en-US" sz="950" dirty="0"/>
           </a:p>
         </p:txBody>
       </p:sp>
@@ -17856,8 +17856,8 @@
         </p:nvSpPr>
         <p:spPr>
           <a:xfrm>
-            <a:off x="6301588" y="5230368"/>
-            <a:ext cx="2282114" cy="384048"/>
+            <a:off x="6283300" y="4352544"/>
+            <a:ext cx="2318690" cy="246888"/>
           </a:xfrm>
           <a:prstGeom prst="rect">
             <a:avLst/>
@@ -17873,14 +17873,14 @@
               <a:buNone/>
             </a:pPr>
             <a:r>
-              <a:rPr lang="en-US" sz="850" dirty="0">
+              <a:rPr lang="en-US" sz="750" dirty="0">
                 <a:solidFill>
                   <a:srgbClr val="6B7684"/>
                 </a:solidFill>
               </a:rPr>
-              <a:t>Role-based email dispatch — farmers, hospitals, NGOs, municipal corps</a:t>
-            </a:r>
-            <a:endParaRPr lang="en-US" sz="850" dirty="0"/>
+              <a:t>OSRM road-network routing with automatic geodesic fallback</a:t>
+            </a:r>
+            <a:endParaRPr lang="en-US" sz="750" dirty="0"/>
           </a:p>
         </p:txBody>
       </p:sp>
@@ -17892,12 +17892,12 @@
         </p:nvSpPr>
         <p:spPr>
           <a:xfrm>
-            <a:off x="8858021" y="4480560"/>
-            <a:ext cx="2556434" cy="1188720"/>
+            <a:off x="8858021" y="3712464"/>
+            <a:ext cx="2556434" cy="896112"/>
           </a:xfrm>
           <a:prstGeom prst="roundRect">
             <a:avLst>
-              <a:gd name="adj" fmla="val 5385"/>
+              <a:gd name="adj" fmla="val 7143"/>
             </a:avLst>
           </a:prstGeom>
           <a:solidFill>
@@ -17919,8 +17919,8 @@
         </p:nvSpPr>
         <p:spPr>
           <a:xfrm>
-            <a:off x="8995181" y="4617720"/>
-            <a:ext cx="274320" cy="274320"/>
+            <a:off x="8976893" y="3831336"/>
+            <a:ext cx="237744" cy="237744"/>
           </a:xfrm>
           <a:prstGeom prst="ellipse">
             <a:avLst/>
@@ -17939,8 +17939,8 @@
         </p:nvSpPr>
         <p:spPr>
           <a:xfrm>
-            <a:off x="8995181" y="4956048"/>
-            <a:ext cx="2282114" cy="274320"/>
+            <a:off x="8976893" y="4114800"/>
+            <a:ext cx="2318690" cy="237744"/>
           </a:xfrm>
           <a:prstGeom prst="rect">
             <a:avLst/>
@@ -17956,27 +17956,146 @@
               <a:buNone/>
             </a:pPr>
             <a:r>
-              <a:rPr lang="en-US" sz="1100" b="1" dirty="0">
+              <a:rPr lang="en-US" sz="950" b="1" dirty="0">
                 <a:solidFill>
                   <a:srgbClr val="0F1B2D"/>
                 </a:solidFill>
               </a:rPr>
+              <a:t>Audience-Tailored Alerts</a:t>
+            </a:r>
+            <a:endParaRPr lang="en-US" sz="950" dirty="0"/>
+          </a:p>
+        </p:txBody>
+      </p:sp>
+      <p:sp>
+        <p:nvSpPr>
+          <p:cNvPr id="55" name="Text 52"/>
+          <p:cNvSpPr txBox="1"/>
+          <p:nvPr/>
+        </p:nvSpPr>
+        <p:spPr>
+          <a:xfrm>
+            <a:off x="8976893" y="4352544"/>
+            <a:ext cx="2318690" cy="246888"/>
+          </a:xfrm>
+          <a:prstGeom prst="rect">
+            <a:avLst/>
+          </a:prstGeom>
+          <a:noFill/>
+          <a:ln/>
+        </p:spPr>
+        <p:txBody>
+          <a:bodyPr wrap="square" lIns="0" tIns="0" rIns="0" bIns="0" rtlCol="0" anchor="t"/>
+          <a:lstStyle/>
+          <a:p>
+            <a:pPr indent="0" marL="0">
+              <a:buNone/>
+            </a:pPr>
+            <a:r>
+              <a:rPr lang="en-US" sz="750" dirty="0">
+                <a:solidFill>
+                  <a:srgbClr val="6B7684"/>
+                </a:solidFill>
+              </a:rPr>
+              <a:t>Role-based email dispatch — farmers, hospitals, NGOs, municipal corps</a:t>
+            </a:r>
+            <a:endParaRPr lang="en-US" sz="750" dirty="0"/>
+          </a:p>
+        </p:txBody>
+      </p:sp>
+      <p:sp>
+        <p:nvSpPr>
+          <p:cNvPr id="56" name="Shape 53"/>
+          <p:cNvSpPr/>
+          <p:nvPr/>
+        </p:nvSpPr>
+        <p:spPr>
+          <a:xfrm>
+            <a:off x="777240" y="4700016"/>
+            <a:ext cx="2556434" cy="896112"/>
+          </a:xfrm>
+          <a:prstGeom prst="roundRect">
+            <a:avLst>
+              <a:gd name="adj" fmla="val 7143"/>
+            </a:avLst>
+          </a:prstGeom>
+          <a:solidFill>
+            <a:srgbClr val="FFFFFF"/>
+          </a:solidFill>
+          <a:ln w="9525">
+            <a:solidFill>
+              <a:srgbClr val="E2E1D6"/>
+            </a:solidFill>
+            <a:prstDash val="solid"/>
+          </a:ln>
+        </p:spPr>
+      </p:sp>
+      <p:sp>
+        <p:nvSpPr>
+          <p:cNvPr id="57" name="Shape 54"/>
+          <p:cNvSpPr/>
+          <p:nvPr/>
+        </p:nvSpPr>
+        <p:spPr>
+          <a:xfrm>
+            <a:off x="896112" y="4818888"/>
+            <a:ext cx="237744" cy="237744"/>
+          </a:xfrm>
+          <a:prstGeom prst="ellipse">
+            <a:avLst/>
+          </a:prstGeom>
+          <a:solidFill>
+            <a:srgbClr val="5B6472"/>
+          </a:solidFill>
+          <a:ln/>
+        </p:spPr>
+      </p:sp>
+      <p:sp>
+        <p:nvSpPr>
+          <p:cNvPr id="58" name="Text 55"/>
+          <p:cNvSpPr txBox="1"/>
+          <p:nvPr/>
+        </p:nvSpPr>
+        <p:spPr>
+          <a:xfrm>
+            <a:off x="896112" y="5102352"/>
+            <a:ext cx="2318690" cy="237744"/>
+          </a:xfrm>
+          <a:prstGeom prst="rect">
+            <a:avLst/>
+          </a:prstGeom>
+          <a:noFill/>
+          <a:ln/>
+        </p:spPr>
+        <p:txBody>
+          <a:bodyPr wrap="square" lIns="0" tIns="0" rIns="0" bIns="0" rtlCol="0" anchor="ctr"/>
+          <a:lstStyle/>
+          <a:p>
+            <a:pPr indent="0" marL="0">
+              <a:buNone/>
+            </a:pPr>
+            <a:r>
+              <a:rPr lang="en-US" sz="950" b="1" dirty="0">
+                <a:solidFill>
+                  <a:srgbClr val="0F1B2D"/>
+                </a:solidFill>
+              </a:rPr>
               <a:t>Multi-Language UI</a:t>
             </a:r>
-            <a:endParaRPr lang="en-US" sz="1100" dirty="0"/>
-          </a:p>
-        </p:txBody>
-      </p:sp>
-      <p:sp>
-        <p:nvSpPr>
-          <p:cNvPr id="55" name="Text 52"/>
-          <p:cNvSpPr txBox="1"/>
-          <p:nvPr/>
-        </p:nvSpPr>
-        <p:spPr>
-          <a:xfrm>
-            <a:off x="8995181" y="5230368"/>
-            <a:ext cx="2282114" cy="384048"/>
+            <a:endParaRPr lang="en-US" sz="950" dirty="0"/>
+          </a:p>
+        </p:txBody>
+      </p:sp>
+      <p:sp>
+        <p:nvSpPr>
+          <p:cNvPr id="59" name="Text 56"/>
+          <p:cNvSpPr txBox="1"/>
+          <p:nvPr/>
+        </p:nvSpPr>
+        <p:spPr>
+          <a:xfrm>
+            <a:off x="896112" y="5340096"/>
+            <a:ext cx="2318690" cy="246888"/>
           </a:xfrm>
           <a:prstGeom prst="rect">
             <a:avLst/>
@@ -17992,26 +18111,26 @@
               <a:buNone/>
             </a:pPr>
             <a:r>
-              <a:rPr lang="en-US" sz="850" dirty="0">
+              <a:rPr lang="en-US" sz="750" dirty="0">
                 <a:solidFill>
                   <a:srgbClr val="6B7684"/>
                 </a:solidFill>
               </a:rPr>
               <a:t>vue-i18n across the dashboard, with interactive Mapbox GL mapping</a:t>
             </a:r>
-            <a:endParaRPr lang="en-US" sz="850" dirty="0"/>
-          </a:p>
-        </p:txBody>
-      </p:sp>
-      <p:sp>
-        <p:nvSpPr>
-          <p:cNvPr id="56" name="Text 53"/>
-          <p:cNvSpPr txBox="1"/>
-          <p:nvPr/>
-        </p:nvSpPr>
-        <p:spPr>
-          <a:xfrm>
-            <a:off x="777240" y="5989320"/>
+            <a:endParaRPr lang="en-US" sz="750" dirty="0"/>
+          </a:p>
+        </p:txBody>
+      </p:sp>
+      <p:sp>
+        <p:nvSpPr>
+          <p:cNvPr id="60" name="Text 57"/>
+          <p:cNvSpPr txBox="1"/>
+          <p:nvPr/>
+        </p:nvSpPr>
+        <p:spPr>
+          <a:xfrm>
+            <a:off x="777240" y="5897880"/>
             <a:ext cx="10637215" cy="365760"/>
           </a:xfrm>
           <a:prstGeom prst="rect">
@@ -18028,14 +18147,14 @@
               <a:buNone/>
             </a:pPr>
             <a:r>
-              <a:rPr lang="en-US" sz="1050" i="1" dirty="0">
+              <a:rPr lang="en-US" sz="1000" i="1" dirty="0">
                 <a:solidFill>
                   <a:srgbClr val="8A8470"/>
                 </a:solidFill>
               </a:rPr>
               <a:t>WhatsApp (WAHA) alerting is built and self-hosted but not yet production-reliable; SMS is in progress — both stay off this list until confirmed.</a:t>
             </a:r>
-            <a:endParaRPr lang="en-US" sz="1050" dirty="0"/>
+            <a:endParaRPr lang="en-US" sz="1000" dirty="0"/>
           </a:p>
         </p:txBody>
       </p:sp>

</xml_diff>

<commit_message>
Restructure Features slide by lifecycle phase (Predict/Prepare/Respond/Recover)
Replaces the flat feature grid with four phase columns so the full
functionality list is visible under each phase. Adds the interactive
Mapbox live map and 7-day forecasting as explicit bullets (previously
undocumented on this slide), and keeps Predict/Recover items consistent
with the wording already used on Brief and Future Development.
</commit_message>
<xml_diff>
--- a/docs/PPT/TerraGrid_AI_Builder_Cup_Submission_copilot_terragrid.pptx
+++ b/docs/PPT/TerraGrid_AI_Builder_Cup_Submission_copilot_terragrid.pptx
@@ -16569,7 +16569,7 @@
                 <a:ea typeface="Cambria" pitchFamily="34" charset="-122"/>
                 <a:cs typeface="Cambria" pitchFamily="34" charset="-120"/>
               </a:rPr>
-              <a:t>Everything Built And Working Today</a:t>
+              <a:t>Features Offered By The Solution</a:t>
             </a:r>
             <a:endParaRPr lang="en-US" sz="2400" dirty="0"/>
           </a:p>
@@ -16584,36 +16584,143 @@
         <p:spPr>
           <a:xfrm>
             <a:off x="777240" y="1737360"/>
-            <a:ext cx="2556434" cy="896112"/>
-          </a:xfrm>
-          <a:prstGeom prst="roundRect">
-            <a:avLst>
-              <a:gd name="adj" fmla="val 7143"/>
-            </a:avLst>
+            <a:ext cx="2556434" cy="54864"/>
+          </a:xfrm>
+          <a:prstGeom prst="rect">
+            <a:avLst/>
+          </a:prstGeom>
+          <a:solidFill>
+            <a:srgbClr val="5B6472"/>
+          </a:solidFill>
+          <a:ln/>
+        </p:spPr>
+      </p:sp>
+      <p:sp>
+        <p:nvSpPr>
+          <p:cNvPr id="9" name="Shape 6"/>
+          <p:cNvSpPr/>
+          <p:nvPr/>
+        </p:nvSpPr>
+        <p:spPr>
+          <a:xfrm>
+            <a:off x="777240" y="1792224"/>
+            <a:ext cx="2556434" cy="3968496"/>
+          </a:xfrm>
+          <a:prstGeom prst="rect">
+            <a:avLst/>
           </a:prstGeom>
           <a:solidFill>
             <a:srgbClr val="FFFFFF"/>
           </a:solidFill>
-          <a:ln w="9525">
-            <a:solidFill>
-              <a:srgbClr val="E2E1D6"/>
-            </a:solidFill>
-            <a:prstDash val="solid"/>
-          </a:ln>
-        </p:spPr>
-      </p:sp>
-      <p:sp>
-        <p:nvSpPr>
-          <p:cNvPr id="9" name="Shape 6"/>
+          <a:ln/>
+        </p:spPr>
+      </p:sp>
+      <p:sp>
+        <p:nvSpPr>
+          <p:cNvPr id="10" name="Text 7"/>
+          <p:cNvSpPr txBox="1"/>
+          <p:nvPr/>
+        </p:nvSpPr>
+        <p:spPr>
+          <a:xfrm>
+            <a:off x="914400" y="1901952"/>
+            <a:ext cx="2282114" cy="320040"/>
+          </a:xfrm>
+          <a:prstGeom prst="rect">
+            <a:avLst/>
+          </a:prstGeom>
+          <a:noFill/>
+          <a:ln/>
+        </p:spPr>
+        <p:txBody>
+          <a:bodyPr wrap="square" lIns="0" tIns="0" rIns="0" bIns="0" rtlCol="0" anchor="ctr"/>
+          <a:lstStyle/>
+          <a:p>
+            <a:pPr indent="0" marL="0">
+              <a:buNone/>
+            </a:pPr>
+            <a:r>
+              <a:rPr lang="en-US" sz="1500" b="1" dirty="0">
+                <a:solidFill>
+                  <a:srgbClr val="5B6472"/>
+                </a:solidFill>
+              </a:rPr>
+              <a:t>Predict</a:t>
+            </a:r>
+            <a:endParaRPr lang="en-US" sz="1500" dirty="0"/>
+          </a:p>
+        </p:txBody>
+      </p:sp>
+      <p:sp>
+        <p:nvSpPr>
+          <p:cNvPr id="11" name="Text 8"/>
+          <p:cNvSpPr txBox="1"/>
+          <p:nvPr/>
+        </p:nvSpPr>
+        <p:spPr>
+          <a:xfrm>
+            <a:off x="914400" y="2286000"/>
+            <a:ext cx="2282114" cy="3337560"/>
+          </a:xfrm>
+          <a:prstGeom prst="rect">
+            <a:avLst/>
+          </a:prstGeom>
+          <a:noFill/>
+          <a:ln/>
+        </p:spPr>
+        <p:txBody>
+          <a:bodyPr wrap="square" lIns="0" tIns="0" rIns="0" bIns="0" rtlCol="0" anchor="t"/>
+          <a:lstStyle/>
+          <a:p>
+            <a:pPr marL="342900" indent="-342900">
+              <a:spcAft>
+                <a:spcPts val="800"/>
+              </a:spcAft>
+              <a:buSzPct val="100000"/>
+              <a:buChar char="✓"/>
+            </a:pPr>
+            <a:r>
+              <a:rPr lang="en-US" sz="1050" dirty="0">
+                <a:solidFill>
+                  <a:srgbClr val="3A4452"/>
+                </a:solidFill>
+              </a:rPr>
+              <a:t>6-month early-warning signal from climate indicators — ENSO, seasonal rainfall outlook</a:t>
+            </a:r>
+            <a:endParaRPr lang="en-US" sz="1050" dirty="0"/>
+          </a:p>
+          <a:p>
+            <a:pPr marL="342900" indent="-342900">
+              <a:spcAft>
+                <a:spcPts val="800"/>
+              </a:spcAft>
+              <a:buSzPct val="100000"/>
+              <a:buChar char="✓"/>
+            </a:pPr>
+            <a:r>
+              <a:rPr lang="en-US" sz="1050" dirty="0">
+                <a:solidFill>
+                  <a:srgbClr val="3A4452"/>
+                </a:solidFill>
+              </a:rPr>
+              <a:t>Surfaced on a climate-signal dashboard</a:t>
+            </a:r>
+            <a:endParaRPr lang="en-US" sz="1050" dirty="0"/>
+          </a:p>
+        </p:txBody>
+      </p:sp>
+      <p:sp>
+        <p:nvSpPr>
+          <p:cNvPr id="12" name="Shape 9"/>
           <p:cNvSpPr/>
           <p:nvPr/>
         </p:nvSpPr>
         <p:spPr>
           <a:xfrm>
-            <a:off x="896112" y="1856232"/>
-            <a:ext cx="237744" cy="237744"/>
-          </a:xfrm>
-          <a:prstGeom prst="ellipse">
+            <a:off x="3470834" y="1737360"/>
+            <a:ext cx="2556434" cy="54864"/>
+          </a:xfrm>
+          <a:prstGeom prst="rect">
             <a:avLst/>
           </a:prstGeom>
           <a:solidFill>
@@ -16624,120 +16731,21 @@
       </p:sp>
       <p:sp>
         <p:nvSpPr>
-          <p:cNvPr id="10" name="Text 7"/>
-          <p:cNvSpPr txBox="1"/>
-          <p:nvPr/>
-        </p:nvSpPr>
-        <p:spPr>
-          <a:xfrm>
-            <a:off x="896112" y="2139696"/>
-            <a:ext cx="2318690" cy="237744"/>
-          </a:xfrm>
-          <a:prstGeom prst="rect">
-            <a:avLst/>
-          </a:prstGeom>
-          <a:noFill/>
-          <a:ln/>
-        </p:spPr>
-        <p:txBody>
-          <a:bodyPr wrap="square" lIns="0" tIns="0" rIns="0" bIns="0" rtlCol="0" anchor="ctr"/>
-          <a:lstStyle/>
-          <a:p>
-            <a:pPr indent="0" marL="0">
-              <a:buNone/>
-            </a:pPr>
-            <a:r>
-              <a:rPr lang="en-US" sz="950" b="1" dirty="0">
-                <a:solidFill>
-                  <a:srgbClr val="0F1B2D"/>
-                </a:solidFill>
-              </a:rPr>
-              <a:t>Multi-Source Intelligence</a:t>
-            </a:r>
-            <a:endParaRPr lang="en-US" sz="950" dirty="0"/>
-          </a:p>
-        </p:txBody>
-      </p:sp>
-      <p:sp>
-        <p:nvSpPr>
-          <p:cNvPr id="11" name="Text 8"/>
-          <p:cNvSpPr txBox="1"/>
-          <p:nvPr/>
-        </p:nvSpPr>
-        <p:spPr>
-          <a:xfrm>
-            <a:off x="896112" y="2377440"/>
-            <a:ext cx="2318690" cy="246888"/>
-          </a:xfrm>
-          <a:prstGeom prst="rect">
-            <a:avLst/>
-          </a:prstGeom>
-          <a:noFill/>
-          <a:ln/>
-        </p:spPr>
-        <p:txBody>
-          <a:bodyPr wrap="square" lIns="0" tIns="0" rIns="0" bIns="0" rtlCol="0" anchor="t"/>
-          <a:lstStyle/>
-          <a:p>
-            <a:pPr indent="0" marL="0">
-              <a:buNone/>
-            </a:pPr>
-            <a:r>
-              <a:rPr lang="en-US" sz="750" dirty="0">
-                <a:solidFill>
-                  <a:srgbClr val="6B7684"/>
-                </a:solidFill>
-              </a:rPr>
-              <a:t>6 live APIs auto-ingested — NASA EONET, USGS, NOAA, GDACS, OpenWeatherMap, OSM/Overpass</a:t>
-            </a:r>
-            <a:endParaRPr lang="en-US" sz="750" dirty="0"/>
-          </a:p>
-        </p:txBody>
-      </p:sp>
-      <p:sp>
-        <p:nvSpPr>
-          <p:cNvPr id="12" name="Shape 9"/>
+          <p:cNvPr id="13" name="Shape 10"/>
           <p:cNvSpPr/>
           <p:nvPr/>
         </p:nvSpPr>
         <p:spPr>
           <a:xfrm>
-            <a:off x="3470834" y="1737360"/>
-            <a:ext cx="2556434" cy="896112"/>
-          </a:xfrm>
-          <a:prstGeom prst="roundRect">
-            <a:avLst>
-              <a:gd name="adj" fmla="val 7143"/>
-            </a:avLst>
+            <a:off x="3470834" y="1792224"/>
+            <a:ext cx="2556434" cy="3968496"/>
+          </a:xfrm>
+          <a:prstGeom prst="rect">
+            <a:avLst/>
           </a:prstGeom>
           <a:solidFill>
             <a:srgbClr val="FFFFFF"/>
           </a:solidFill>
-          <a:ln w="9525">
-            <a:solidFill>
-              <a:srgbClr val="E2E1D6"/>
-            </a:solidFill>
-            <a:prstDash val="solid"/>
-          </a:ln>
-        </p:spPr>
-      </p:sp>
-      <p:sp>
-        <p:nvSpPr>
-          <p:cNvPr id="13" name="Shape 10"/>
-          <p:cNvSpPr/>
-          <p:nvPr/>
-        </p:nvSpPr>
-        <p:spPr>
-          <a:xfrm>
-            <a:off x="3589706" y="1856232"/>
-            <a:ext cx="237744" cy="237744"/>
-          </a:xfrm>
-          <a:prstGeom prst="ellipse">
-            <a:avLst/>
-          </a:prstGeom>
-          <a:solidFill>
-            <a:srgbClr val="0E7490"/>
-          </a:solidFill>
           <a:ln/>
         </p:spPr>
       </p:sp>
@@ -16749,8 +16757,8 @@
         </p:nvSpPr>
         <p:spPr>
           <a:xfrm>
-            <a:off x="3589706" y="2139696"/>
-            <a:ext cx="2318690" cy="237744"/>
+            <a:off x="3607994" y="1901952"/>
+            <a:ext cx="2282114" cy="320040"/>
           </a:xfrm>
           <a:prstGeom prst="rect">
             <a:avLst/>
@@ -16766,14 +16774,14 @@
               <a:buNone/>
             </a:pPr>
             <a:r>
-              <a:rPr lang="en-US" sz="950" b="1" dirty="0">
-                <a:solidFill>
-                  <a:srgbClr val="0F1B2D"/>
-                </a:solidFill>
-              </a:rPr>
-              <a:t>AI Decision Support</a:t>
-            </a:r>
-            <a:endParaRPr lang="en-US" sz="950" dirty="0"/>
+              <a:rPr lang="en-US" sz="1500" b="1" dirty="0">
+                <a:solidFill>
+                  <a:srgbClr val="0E7490"/>
+                </a:solidFill>
+              </a:rPr>
+              <a:t>Prepare</a:t>
+            </a:r>
+            <a:endParaRPr lang="en-US" sz="1500" dirty="0"/>
           </a:p>
         </p:txBody>
       </p:sp>
@@ -16785,8 +16793,8 @@
         </p:nvSpPr>
         <p:spPr>
           <a:xfrm>
-            <a:off x="3589706" y="2377440"/>
-            <a:ext cx="2318690" cy="246888"/>
+            <a:off x="3607994" y="2286000"/>
+            <a:ext cx="2282114" cy="3337560"/>
           </a:xfrm>
           <a:prstGeom prst="rect">
             <a:avLst/>
@@ -16798,18 +16806,94 @@
           <a:bodyPr wrap="square" lIns="0" tIns="0" rIns="0" bIns="0" rtlCol="0" anchor="t"/>
           <a:lstStyle/>
           <a:p>
-            <a:pPr indent="0" marL="0">
-              <a:buNone/>
-            </a:pPr>
-            <a:r>
-              <a:rPr lang="en-US" sz="750" dirty="0">
-                <a:solidFill>
-                  <a:srgbClr val="6B7684"/>
-                </a:solidFill>
-              </a:rPr>
-              <a:t>Gemini 2.5 Flash generates action plans with confidence scoring</a:t>
-            </a:r>
-            <a:endParaRPr lang="en-US" sz="750" dirty="0"/>
+            <a:pPr marL="342900" indent="-342900">
+              <a:spcAft>
+                <a:spcPts val="800"/>
+              </a:spcAft>
+              <a:buSzPct val="100000"/>
+              <a:buChar char="✓"/>
+            </a:pPr>
+            <a:r>
+              <a:rPr lang="en-US" sz="1050" dirty="0">
+                <a:solidFill>
+                  <a:srgbClr val="3A4452"/>
+                </a:solidFill>
+              </a:rPr>
+              <a:t>7-day risk forecasting across 8 cities</a:t>
+            </a:r>
+            <a:endParaRPr lang="en-US" sz="1050" dirty="0"/>
+          </a:p>
+          <a:p>
+            <a:pPr marL="342900" indent="-342900">
+              <a:spcAft>
+                <a:spcPts val="800"/>
+              </a:spcAft>
+              <a:buSzPct val="100000"/>
+              <a:buChar char="✓"/>
+            </a:pPr>
+            <a:r>
+              <a:rPr lang="en-US" sz="1050" dirty="0">
+                <a:solidFill>
+                  <a:srgbClr val="3A4452"/>
+                </a:solidFill>
+              </a:rPr>
+              <a:t>AI-generated risk-escalation timeline</a:t>
+            </a:r>
+            <a:endParaRPr lang="en-US" sz="1050" dirty="0"/>
+          </a:p>
+          <a:p>
+            <a:pPr marL="342900" indent="-342900">
+              <a:spcAft>
+                <a:spcPts val="800"/>
+              </a:spcAft>
+              <a:buSzPct val="100000"/>
+              <a:buChar char="✓"/>
+            </a:pPr>
+            <a:r>
+              <a:rPr lang="en-US" sz="1050" dirty="0">
+                <a:solidFill>
+                  <a:srgbClr val="3A4452"/>
+                </a:solidFill>
+              </a:rPr>
+              <a:t>Preparedness checklists, auto-generated per agency</a:t>
+            </a:r>
+            <a:endParaRPr lang="en-US" sz="1050" dirty="0"/>
+          </a:p>
+          <a:p>
+            <a:pPr marL="342900" indent="-342900">
+              <a:spcAft>
+                <a:spcPts val="800"/>
+              </a:spcAft>
+              <a:buSzPct val="100000"/>
+              <a:buChar char="✓"/>
+            </a:pPr>
+            <a:r>
+              <a:rPr lang="en-US" sz="1050" dirty="0">
+                <a:solidFill>
+                  <a:srgbClr val="3A4452"/>
+                </a:solidFill>
+              </a:rPr>
+              <a:t>Automated agency alert drafting</a:t>
+            </a:r>
+            <a:endParaRPr lang="en-US" sz="1050" dirty="0"/>
+          </a:p>
+          <a:p>
+            <a:pPr marL="342900" indent="-342900">
+              <a:spcAft>
+                <a:spcPts val="800"/>
+              </a:spcAft>
+              <a:buSzPct val="100000"/>
+              <a:buChar char="✓"/>
+            </a:pPr>
+            <a:r>
+              <a:rPr lang="en-US" sz="1050" dirty="0">
+                <a:solidFill>
+                  <a:srgbClr val="3A4452"/>
+                </a:solidFill>
+              </a:rPr>
+              <a:t>Source of Truth — 4-layer data lineage per incident</a:t>
+            </a:r>
+            <a:endParaRPr lang="en-US" sz="1050" dirty="0"/>
           </a:p>
         </p:txBody>
       </p:sp>
@@ -16822,41 +16906,34 @@
         <p:spPr>
           <a:xfrm>
             <a:off x="6164428" y="1737360"/>
-            <a:ext cx="2556434" cy="896112"/>
-          </a:xfrm>
-          <a:prstGeom prst="roundRect">
-            <a:avLst>
-              <a:gd name="adj" fmla="val 7143"/>
-            </a:avLst>
+            <a:ext cx="2556434" cy="54864"/>
+          </a:xfrm>
+          <a:prstGeom prst="rect">
+            <a:avLst/>
+          </a:prstGeom>
+          <a:solidFill>
+            <a:srgbClr val="E8722C"/>
+          </a:solidFill>
+          <a:ln/>
+        </p:spPr>
+      </p:sp>
+      <p:sp>
+        <p:nvSpPr>
+          <p:cNvPr id="17" name="Shape 14"/>
+          <p:cNvSpPr/>
+          <p:nvPr/>
+        </p:nvSpPr>
+        <p:spPr>
+          <a:xfrm>
+            <a:off x="6164428" y="1792224"/>
+            <a:ext cx="2556434" cy="3968496"/>
+          </a:xfrm>
+          <a:prstGeom prst="rect">
+            <a:avLst/>
           </a:prstGeom>
           <a:solidFill>
             <a:srgbClr val="FFFFFF"/>
           </a:solidFill>
-          <a:ln w="9525">
-            <a:solidFill>
-              <a:srgbClr val="E2E1D6"/>
-            </a:solidFill>
-            <a:prstDash val="solid"/>
-          </a:ln>
-        </p:spPr>
-      </p:sp>
-      <p:sp>
-        <p:nvSpPr>
-          <p:cNvPr id="17" name="Shape 14"/>
-          <p:cNvSpPr/>
-          <p:nvPr/>
-        </p:nvSpPr>
-        <p:spPr>
-          <a:xfrm>
-            <a:off x="6283300" y="1856232"/>
-            <a:ext cx="237744" cy="237744"/>
-          </a:xfrm>
-          <a:prstGeom prst="ellipse">
-            <a:avLst/>
-          </a:prstGeom>
-          <a:solidFill>
-            <a:srgbClr val="0E7490"/>
-          </a:solidFill>
           <a:ln/>
         </p:spPr>
       </p:sp>
@@ -16868,8 +16945,8 @@
         </p:nvSpPr>
         <p:spPr>
           <a:xfrm>
-            <a:off x="6283300" y="2139696"/>
-            <a:ext cx="2318690" cy="237744"/>
+            <a:off x="6301588" y="1901952"/>
+            <a:ext cx="2282114" cy="320040"/>
           </a:xfrm>
           <a:prstGeom prst="rect">
             <a:avLst/>
@@ -16885,14 +16962,14 @@
               <a:buNone/>
             </a:pPr>
             <a:r>
-              <a:rPr lang="en-US" sz="950" b="1" dirty="0">
-                <a:solidFill>
-                  <a:srgbClr val="0F1B2D"/>
-                </a:solidFill>
-              </a:rPr>
-              <a:t>Satellite Verification</a:t>
-            </a:r>
-            <a:endParaRPr lang="en-US" sz="950" dirty="0"/>
+              <a:rPr lang="en-US" sz="1500" b="1" dirty="0">
+                <a:solidFill>
+                  <a:srgbClr val="E8722C"/>
+                </a:solidFill>
+              </a:rPr>
+              <a:t>Respond</a:t>
+            </a:r>
+            <a:endParaRPr lang="en-US" sz="1500" dirty="0"/>
           </a:p>
         </p:txBody>
       </p:sp>
@@ -16904,8 +16981,8 @@
         </p:nvSpPr>
         <p:spPr>
           <a:xfrm>
-            <a:off x="6283300" y="2377440"/>
-            <a:ext cx="2318690" cy="246888"/>
+            <a:off x="6301588" y="2286000"/>
+            <a:ext cx="2282114" cy="3337560"/>
           </a:xfrm>
           <a:prstGeom prst="rect">
             <a:avLst/>
@@ -16917,18 +16994,184 @@
           <a:bodyPr wrap="square" lIns="0" tIns="0" rIns="0" bIns="0" rtlCol="0" anchor="t"/>
           <a:lstStyle/>
           <a:p>
-            <a:pPr indent="0" marL="0">
-              <a:buNone/>
-            </a:pPr>
-            <a:r>
-              <a:rPr lang="en-US" sz="750" dirty="0">
-                <a:solidFill>
-                  <a:srgbClr val="6B7684"/>
-                </a:solidFill>
-              </a:rPr>
-              <a:t>Sentinel-1 SAR cross-validation via Google Earth Engine</a:t>
-            </a:r>
-            <a:endParaRPr lang="en-US" sz="750" dirty="0"/>
+            <a:pPr marL="342900" indent="-342900">
+              <a:spcAft>
+                <a:spcPts val="400"/>
+              </a:spcAft>
+              <a:buSzPct val="100000"/>
+              <a:buChar char="✓"/>
+            </a:pPr>
+            <a:r>
+              <a:rPr lang="en-US" sz="830" dirty="0">
+                <a:solidFill>
+                  <a:srgbClr val="3A4452"/>
+                </a:solidFill>
+              </a:rPr>
+              <a:t>Interactive Mapbox GL live map with real-time incident markers</a:t>
+            </a:r>
+            <a:endParaRPr lang="en-US" sz="830" dirty="0"/>
+          </a:p>
+          <a:p>
+            <a:pPr marL="342900" indent="-342900">
+              <a:spcAft>
+                <a:spcPts val="400"/>
+              </a:spcAft>
+              <a:buSzPct val="100000"/>
+              <a:buChar char="✓"/>
+            </a:pPr>
+            <a:r>
+              <a:rPr lang="en-US" sz="830" dirty="0">
+                <a:solidFill>
+                  <a:srgbClr val="3A4452"/>
+                </a:solidFill>
+              </a:rPr>
+              <a:t>Live multi-hazard incident dashboard — map + detail panel</a:t>
+            </a:r>
+            <a:endParaRPr lang="en-US" sz="830" dirty="0"/>
+          </a:p>
+          <a:p>
+            <a:pPr marL="342900" indent="-342900">
+              <a:spcAft>
+                <a:spcPts val="400"/>
+              </a:spcAft>
+              <a:buSzPct val="100000"/>
+              <a:buChar char="✓"/>
+            </a:pPr>
+            <a:r>
+              <a:rPr lang="en-US" sz="830" dirty="0">
+                <a:solidFill>
+                  <a:srgbClr val="3A4452"/>
+                </a:solidFill>
+              </a:rPr>
+              <a:t>Real-time WebSocket updates across the dashboard</a:t>
+            </a:r>
+            <a:endParaRPr lang="en-US" sz="830" dirty="0"/>
+          </a:p>
+          <a:p>
+            <a:pPr marL="342900" indent="-342900">
+              <a:spcAft>
+                <a:spcPts val="400"/>
+              </a:spcAft>
+              <a:buSzPct val="100000"/>
+              <a:buChar char="✓"/>
+            </a:pPr>
+            <a:r>
+              <a:rPr lang="en-US" sz="830" dirty="0">
+                <a:solidFill>
+                  <a:srgbClr val="3A4452"/>
+                </a:solidFill>
+              </a:rPr>
+              <a:t>Gemini 2.5 Flash decision support with confidence scoring</a:t>
+            </a:r>
+            <a:endParaRPr lang="en-US" sz="830" dirty="0"/>
+          </a:p>
+          <a:p>
+            <a:pPr marL="342900" indent="-342900">
+              <a:spcAft>
+                <a:spcPts val="400"/>
+              </a:spcAft>
+              <a:buSzPct val="100000"/>
+              <a:buChar char="✓"/>
+            </a:pPr>
+            <a:r>
+              <a:rPr lang="en-US" sz="830" dirty="0">
+                <a:solidFill>
+                  <a:srgbClr val="3A4452"/>
+                </a:solidFill>
+              </a:rPr>
+              <a:t>Satellite cross-validation — Sentinel-1 SAR via Google Earth Engine</a:t>
+            </a:r>
+            <a:endParaRPr lang="en-US" sz="830" dirty="0"/>
+          </a:p>
+          <a:p>
+            <a:pPr marL="342900" indent="-342900">
+              <a:spcAft>
+                <a:spcPts val="400"/>
+              </a:spcAft>
+              <a:buSzPct val="100000"/>
+              <a:buChar char="✓"/>
+            </a:pPr>
+            <a:r>
+              <a:rPr lang="en-US" sz="830" dirty="0">
+                <a:solidFill>
+                  <a:srgbClr val="3A4452"/>
+                </a:solidFill>
+              </a:rPr>
+              <a:t>Evacuation-route pre-calculation — OSRM + geodesic fallback</a:t>
+            </a:r>
+            <a:endParaRPr lang="en-US" sz="830" dirty="0"/>
+          </a:p>
+          <a:p>
+            <a:pPr marL="342900" indent="-342900">
+              <a:spcAft>
+                <a:spcPts val="400"/>
+              </a:spcAft>
+              <a:buSzPct val="100000"/>
+              <a:buChar char="✓"/>
+            </a:pPr>
+            <a:r>
+              <a:rPr lang="en-US" sz="830" dirty="0">
+                <a:solidFill>
+                  <a:srgbClr val="3A4452"/>
+                </a:solidFill>
+              </a:rPr>
+              <a:t>Audience-tailored email alerts — farmers, hospitals, NGOs, municipal corps</a:t>
+            </a:r>
+            <a:endParaRPr lang="en-US" sz="830" dirty="0"/>
+          </a:p>
+          <a:p>
+            <a:pPr marL="342900" indent="-342900">
+              <a:spcAft>
+                <a:spcPts val="400"/>
+              </a:spcAft>
+              <a:buSzPct val="100000"/>
+              <a:buChar char="✓"/>
+            </a:pPr>
+            <a:r>
+              <a:rPr lang="en-US" sz="830" dirty="0">
+                <a:solidFill>
+                  <a:srgbClr val="3A4452"/>
+                </a:solidFill>
+              </a:rPr>
+              <a:t>Decision-lineage logging for every AI output</a:t>
+            </a:r>
+            <a:endParaRPr lang="en-US" sz="830" dirty="0"/>
+          </a:p>
+          <a:p>
+            <a:pPr marL="342900" indent="-342900">
+              <a:spcAft>
+                <a:spcPts val="400"/>
+              </a:spcAft>
+              <a:buSzPct val="100000"/>
+              <a:buChar char="✓"/>
+            </a:pPr>
+            <a:r>
+              <a:rPr lang="en-US" sz="830" dirty="0">
+                <a:solidFill>
+                  <a:srgbClr val="3A4452"/>
+                </a:solidFill>
+              </a:rPr>
+              <a:t>Multi-source live ingestion — 6 APIs (NASA EONET, USGS, NOAA, GDACS, OpenWeatherMap, OSM/Overpass)</a:t>
+            </a:r>
+            <a:endParaRPr lang="en-US" sz="830" dirty="0"/>
+          </a:p>
+          <a:p>
+            <a:pPr marL="342900" indent="-342900">
+              <a:spcAft>
+                <a:spcPts val="400"/>
+              </a:spcAft>
+              <a:buSzPct val="100000"/>
+              <a:buChar char="✓"/>
+            </a:pPr>
+            <a:r>
+              <a:rPr lang="en-US" sz="830" dirty="0">
+                <a:solidFill>
+                  <a:srgbClr val="3A4452"/>
+                </a:solidFill>
+              </a:rPr>
+              <a:t>Multi-language UI (vue-i18n)</a:t>
+            </a:r>
+            <a:endParaRPr lang="en-US" sz="830" dirty="0"/>
           </a:p>
         </p:txBody>
       </p:sp>
@@ -16941,41 +17184,34 @@
         <p:spPr>
           <a:xfrm>
             <a:off x="8858021" y="1737360"/>
-            <a:ext cx="2556434" cy="896112"/>
-          </a:xfrm>
-          <a:prstGeom prst="roundRect">
-            <a:avLst>
-              <a:gd name="adj" fmla="val 7143"/>
-            </a:avLst>
+            <a:ext cx="2556434" cy="54864"/>
+          </a:xfrm>
+          <a:prstGeom prst="rect">
+            <a:avLst/>
+          </a:prstGeom>
+          <a:solidFill>
+            <a:srgbClr val="5B6472"/>
+          </a:solidFill>
+          <a:ln/>
+        </p:spPr>
+      </p:sp>
+      <p:sp>
+        <p:nvSpPr>
+          <p:cNvPr id="21" name="Shape 18"/>
+          <p:cNvSpPr/>
+          <p:nvPr/>
+        </p:nvSpPr>
+        <p:spPr>
+          <a:xfrm>
+            <a:off x="8858021" y="1792224"/>
+            <a:ext cx="2556434" cy="3968496"/>
+          </a:xfrm>
+          <a:prstGeom prst="rect">
+            <a:avLst/>
           </a:prstGeom>
           <a:solidFill>
             <a:srgbClr val="FFFFFF"/>
           </a:solidFill>
-          <a:ln w="9525">
-            <a:solidFill>
-              <a:srgbClr val="E2E1D6"/>
-            </a:solidFill>
-            <a:prstDash val="solid"/>
-          </a:ln>
-        </p:spPr>
-      </p:sp>
-      <p:sp>
-        <p:nvSpPr>
-          <p:cNvPr id="21" name="Shape 18"/>
-          <p:cNvSpPr/>
-          <p:nvPr/>
-        </p:nvSpPr>
-        <p:spPr>
-          <a:xfrm>
-            <a:off x="8976893" y="1856232"/>
-            <a:ext cx="237744" cy="237744"/>
-          </a:xfrm>
-          <a:prstGeom prst="ellipse">
-            <a:avLst/>
-          </a:prstGeom>
-          <a:solidFill>
-            <a:srgbClr val="0E7490"/>
-          </a:solidFill>
           <a:ln/>
         </p:spPr>
       </p:sp>
@@ -16987,8 +17223,8 @@
         </p:nvSpPr>
         <p:spPr>
           <a:xfrm>
-            <a:off x="8976893" y="2139696"/>
-            <a:ext cx="2318690" cy="237744"/>
+            <a:off x="8995181" y="1901952"/>
+            <a:ext cx="2282114" cy="320040"/>
           </a:xfrm>
           <a:prstGeom prst="rect">
             <a:avLst/>
@@ -17004,14 +17240,14 @@
               <a:buNone/>
             </a:pPr>
             <a:r>
-              <a:rPr lang="en-US" sz="950" b="1" dirty="0">
-                <a:solidFill>
-                  <a:srgbClr val="0F1B2D"/>
-                </a:solidFill>
-              </a:rPr>
-              <a:t>Decision Lineage</a:t>
-            </a:r>
-            <a:endParaRPr lang="en-US" sz="950" dirty="0"/>
+              <a:rPr lang="en-US" sz="1500" b="1" dirty="0">
+                <a:solidFill>
+                  <a:srgbClr val="5B6472"/>
+                </a:solidFill>
+              </a:rPr>
+              <a:t>Recover</a:t>
+            </a:r>
+            <a:endParaRPr lang="en-US" sz="1500" dirty="0"/>
           </a:p>
         </p:txBody>
       </p:sp>
@@ -17023,8 +17259,8 @@
         </p:nvSpPr>
         <p:spPr>
           <a:xfrm>
-            <a:off x="8976893" y="2377440"/>
-            <a:ext cx="2318690" cy="246888"/>
+            <a:off x="8995181" y="2286000"/>
+            <a:ext cx="2282114" cy="3337560"/>
           </a:xfrm>
           <a:prstGeom prst="rect">
             <a:avLst/>
@@ -17036,1095 +17272,46 @@
           <a:bodyPr wrap="square" lIns="0" tIns="0" rIns="0" bIns="0" rtlCol="0" anchor="t"/>
           <a:lstStyle/>
           <a:p>
-            <a:pPr indent="0" marL="0">
-              <a:buNone/>
-            </a:pPr>
-            <a:r>
-              <a:rPr lang="en-US" sz="750" dirty="0">
-                <a:solidFill>
-                  <a:srgbClr val="6B7684"/>
-                </a:solidFill>
-              </a:rPr>
-              <a:t>Every AI output logged as a timestamped, auditable record</a:t>
-            </a:r>
-            <a:endParaRPr lang="en-US" sz="750" dirty="0"/>
-          </a:p>
-        </p:txBody>
-      </p:sp>
-      <p:sp>
-        <p:nvSpPr>
-          <p:cNvPr id="24" name="Shape 21"/>
-          <p:cNvSpPr/>
-          <p:nvPr/>
-        </p:nvSpPr>
-        <p:spPr>
-          <a:xfrm>
-            <a:off x="777240" y="2724912"/>
-            <a:ext cx="2556434" cy="896112"/>
-          </a:xfrm>
-          <a:prstGeom prst="roundRect">
-            <a:avLst>
-              <a:gd name="adj" fmla="val 7143"/>
-            </a:avLst>
-          </a:prstGeom>
-          <a:solidFill>
-            <a:srgbClr val="FFFFFF"/>
-          </a:solidFill>
-          <a:ln w="9525">
-            <a:solidFill>
-              <a:srgbClr val="E2E1D6"/>
-            </a:solidFill>
-            <a:prstDash val="solid"/>
-          </a:ln>
-        </p:spPr>
-      </p:sp>
-      <p:sp>
-        <p:nvSpPr>
-          <p:cNvPr id="25" name="Shape 22"/>
-          <p:cNvSpPr/>
-          <p:nvPr/>
-        </p:nvSpPr>
-        <p:spPr>
-          <a:xfrm>
-            <a:off x="896112" y="2843784"/>
-            <a:ext cx="237744" cy="237744"/>
-          </a:xfrm>
-          <a:prstGeom prst="ellipse">
-            <a:avLst/>
-          </a:prstGeom>
-          <a:solidFill>
-            <a:srgbClr val="0E7490"/>
-          </a:solidFill>
-          <a:ln/>
-        </p:spPr>
-      </p:sp>
-      <p:sp>
-        <p:nvSpPr>
-          <p:cNvPr id="26" name="Text 23"/>
-          <p:cNvSpPr txBox="1"/>
-          <p:nvPr/>
-        </p:nvSpPr>
-        <p:spPr>
-          <a:xfrm>
-            <a:off x="896112" y="3127248"/>
-            <a:ext cx="2318690" cy="237744"/>
-          </a:xfrm>
-          <a:prstGeom prst="rect">
-            <a:avLst/>
-          </a:prstGeom>
-          <a:noFill/>
-          <a:ln/>
-        </p:spPr>
-        <p:txBody>
-          <a:bodyPr wrap="square" lIns="0" tIns="0" rIns="0" bIns="0" rtlCol="0" anchor="ctr"/>
-          <a:lstStyle/>
-          <a:p>
-            <a:pPr indent="0" marL="0">
-              <a:buNone/>
-            </a:pPr>
-            <a:r>
-              <a:rPr lang="en-US" sz="950" b="1" dirty="0">
-                <a:solidFill>
-                  <a:srgbClr val="0F1B2D"/>
-                </a:solidFill>
-              </a:rPr>
-              <a:t>Source Of Truth</a:t>
-            </a:r>
-            <a:endParaRPr lang="en-US" sz="950" dirty="0"/>
-          </a:p>
-        </p:txBody>
-      </p:sp>
-      <p:sp>
-        <p:nvSpPr>
-          <p:cNvPr id="27" name="Text 24"/>
-          <p:cNvSpPr txBox="1"/>
-          <p:nvPr/>
-        </p:nvSpPr>
-        <p:spPr>
-          <a:xfrm>
-            <a:off x="896112" y="3364992"/>
-            <a:ext cx="2318690" cy="246888"/>
-          </a:xfrm>
-          <a:prstGeom prst="rect">
-            <a:avLst/>
-          </a:prstGeom>
-          <a:noFill/>
-          <a:ln/>
-        </p:spPr>
-        <p:txBody>
-          <a:bodyPr wrap="square" lIns="0" tIns="0" rIns="0" bIns="0" rtlCol="0" anchor="t"/>
-          <a:lstStyle/>
-          <a:p>
-            <a:pPr indent="0" marL="0">
-              <a:buNone/>
-            </a:pPr>
-            <a:r>
-              <a:rPr lang="en-US" sz="750" dirty="0">
-                <a:solidFill>
-                  <a:srgbClr val="6B7684"/>
-                </a:solidFill>
-              </a:rPr>
-              <a:t>4-layer data lineage — raw -&gt; validated -&gt; enriched -&gt; stored — tracked per incident, with its own audit tab in the UI</a:t>
-            </a:r>
-            <a:endParaRPr lang="en-US" sz="750" dirty="0"/>
-          </a:p>
-        </p:txBody>
-      </p:sp>
-      <p:sp>
-        <p:nvSpPr>
-          <p:cNvPr id="28" name="Shape 25"/>
-          <p:cNvSpPr/>
-          <p:nvPr/>
-        </p:nvSpPr>
-        <p:spPr>
-          <a:xfrm>
-            <a:off x="3470834" y="2724912"/>
-            <a:ext cx="2556434" cy="896112"/>
-          </a:xfrm>
-          <a:prstGeom prst="roundRect">
-            <a:avLst>
-              <a:gd name="adj" fmla="val 7143"/>
-            </a:avLst>
-          </a:prstGeom>
-          <a:solidFill>
-            <a:srgbClr val="FFFFFF"/>
-          </a:solidFill>
-          <a:ln w="9525">
-            <a:solidFill>
-              <a:srgbClr val="E2E1D6"/>
-            </a:solidFill>
-            <a:prstDash val="solid"/>
-          </a:ln>
-        </p:spPr>
-      </p:sp>
-      <p:sp>
-        <p:nvSpPr>
-          <p:cNvPr id="29" name="Shape 26"/>
-          <p:cNvSpPr/>
-          <p:nvPr/>
-        </p:nvSpPr>
-        <p:spPr>
-          <a:xfrm>
-            <a:off x="3589706" y="2843784"/>
-            <a:ext cx="237744" cy="237744"/>
-          </a:xfrm>
-          <a:prstGeom prst="ellipse">
-            <a:avLst/>
-          </a:prstGeom>
-          <a:solidFill>
-            <a:srgbClr val="E8722C"/>
-          </a:solidFill>
-          <a:ln/>
-        </p:spPr>
-      </p:sp>
-      <p:sp>
-        <p:nvSpPr>
-          <p:cNvPr id="30" name="Text 27"/>
-          <p:cNvSpPr txBox="1"/>
-          <p:nvPr/>
-        </p:nvSpPr>
-        <p:spPr>
-          <a:xfrm>
-            <a:off x="3589706" y="3127248"/>
-            <a:ext cx="2318690" cy="237744"/>
-          </a:xfrm>
-          <a:prstGeom prst="rect">
-            <a:avLst/>
-          </a:prstGeom>
-          <a:noFill/>
-          <a:ln/>
-        </p:spPr>
-        <p:txBody>
-          <a:bodyPr wrap="square" lIns="0" tIns="0" rIns="0" bIns="0" rtlCol="0" anchor="ctr"/>
-          <a:lstStyle/>
-          <a:p>
-            <a:pPr indent="0" marL="0">
-              <a:buNone/>
-            </a:pPr>
-            <a:r>
-              <a:rPr lang="en-US" sz="950" b="1" dirty="0">
-                <a:solidFill>
-                  <a:srgbClr val="0F1B2D"/>
-                </a:solidFill>
-              </a:rPr>
-              <a:t>7-Day Risk Forecasting</a:t>
-            </a:r>
-            <a:endParaRPr lang="en-US" sz="950" dirty="0"/>
-          </a:p>
-        </p:txBody>
-      </p:sp>
-      <p:sp>
-        <p:nvSpPr>
-          <p:cNvPr id="31" name="Text 28"/>
-          <p:cNvSpPr txBox="1"/>
-          <p:nvPr/>
-        </p:nvSpPr>
-        <p:spPr>
-          <a:xfrm>
-            <a:off x="3589706" y="3364992"/>
-            <a:ext cx="2318690" cy="246888"/>
-          </a:xfrm>
-          <a:prstGeom prst="rect">
-            <a:avLst/>
-          </a:prstGeom>
-          <a:noFill/>
-          <a:ln/>
-        </p:spPr>
-        <p:txBody>
-          <a:bodyPr wrap="square" lIns="0" tIns="0" rIns="0" bIns="0" rtlCol="0" anchor="t"/>
-          <a:lstStyle/>
-          <a:p>
-            <a:pPr indent="0" marL="0">
-              <a:buNone/>
-            </a:pPr>
-            <a:r>
-              <a:rPr lang="en-US" sz="750" dirty="0">
-                <a:solidFill>
-                  <a:srgbClr val="6B7684"/>
-                </a:solidFill>
-              </a:rPr>
-              <a:t>Rolling forecasts across 8 cities, updated continuously</a:t>
-            </a:r>
-            <a:endParaRPr lang="en-US" sz="750" dirty="0"/>
-          </a:p>
-        </p:txBody>
-      </p:sp>
-      <p:sp>
-        <p:nvSpPr>
-          <p:cNvPr id="32" name="Shape 29"/>
-          <p:cNvSpPr/>
-          <p:nvPr/>
-        </p:nvSpPr>
-        <p:spPr>
-          <a:xfrm>
-            <a:off x="6164428" y="2724912"/>
-            <a:ext cx="2556434" cy="896112"/>
-          </a:xfrm>
-          <a:prstGeom prst="roundRect">
-            <a:avLst>
-              <a:gd name="adj" fmla="val 7143"/>
-            </a:avLst>
-          </a:prstGeom>
-          <a:solidFill>
-            <a:srgbClr val="FFFFFF"/>
-          </a:solidFill>
-          <a:ln w="9525">
-            <a:solidFill>
-              <a:srgbClr val="E2E1D6"/>
-            </a:solidFill>
-            <a:prstDash val="solid"/>
-          </a:ln>
-        </p:spPr>
-      </p:sp>
-      <p:sp>
-        <p:nvSpPr>
-          <p:cNvPr id="33" name="Shape 30"/>
-          <p:cNvSpPr/>
-          <p:nvPr/>
-        </p:nvSpPr>
-        <p:spPr>
-          <a:xfrm>
-            <a:off x="6283300" y="2843784"/>
-            <a:ext cx="237744" cy="237744"/>
-          </a:xfrm>
-          <a:prstGeom prst="ellipse">
-            <a:avLst/>
-          </a:prstGeom>
-          <a:solidFill>
-            <a:srgbClr val="E8722C"/>
-          </a:solidFill>
-          <a:ln/>
-        </p:spPr>
-      </p:sp>
-      <p:sp>
-        <p:nvSpPr>
-          <p:cNvPr id="34" name="Text 31"/>
-          <p:cNvSpPr txBox="1"/>
-          <p:nvPr/>
-        </p:nvSpPr>
-        <p:spPr>
-          <a:xfrm>
-            <a:off x="6283300" y="3127248"/>
-            <a:ext cx="2318690" cy="237744"/>
-          </a:xfrm>
-          <a:prstGeom prst="rect">
-            <a:avLst/>
-          </a:prstGeom>
-          <a:noFill/>
-          <a:ln/>
-        </p:spPr>
-        <p:txBody>
-          <a:bodyPr wrap="square" lIns="0" tIns="0" rIns="0" bIns="0" rtlCol="0" anchor="ctr"/>
-          <a:lstStyle/>
-          <a:p>
-            <a:pPr indent="0" marL="0">
-              <a:buNone/>
-            </a:pPr>
-            <a:r>
-              <a:rPr lang="en-US" sz="950" b="1" dirty="0">
-                <a:solidFill>
-                  <a:srgbClr val="0F1B2D"/>
-                </a:solidFill>
-              </a:rPr>
-              <a:t>Risk-Escalation Timeline</a:t>
-            </a:r>
-            <a:endParaRPr lang="en-US" sz="950" dirty="0"/>
-          </a:p>
-        </p:txBody>
-      </p:sp>
-      <p:sp>
-        <p:nvSpPr>
-          <p:cNvPr id="35" name="Text 32"/>
-          <p:cNvSpPr txBox="1"/>
-          <p:nvPr/>
-        </p:nvSpPr>
-        <p:spPr>
-          <a:xfrm>
-            <a:off x="6283300" y="3364992"/>
-            <a:ext cx="2318690" cy="246888"/>
-          </a:xfrm>
-          <a:prstGeom prst="rect">
-            <a:avLst/>
-          </a:prstGeom>
-          <a:noFill/>
-          <a:ln/>
-        </p:spPr>
-        <p:txBody>
-          <a:bodyPr wrap="square" lIns="0" tIns="0" rIns="0" bIns="0" rtlCol="0" anchor="t"/>
-          <a:lstStyle/>
-          <a:p>
-            <a:pPr indent="0" marL="0">
-              <a:buNone/>
-            </a:pPr>
-            <a:r>
-              <a:rPr lang="en-US" sz="750" dirty="0">
-                <a:solidFill>
-                  <a:srgbClr val="6B7684"/>
-                </a:solidFill>
-              </a:rPr>
-              <a:t>AI-generated, phase-by-phase escalation outlook</a:t>
-            </a:r>
-            <a:endParaRPr lang="en-US" sz="750" dirty="0"/>
-          </a:p>
-        </p:txBody>
-      </p:sp>
-      <p:sp>
-        <p:nvSpPr>
-          <p:cNvPr id="36" name="Shape 33"/>
-          <p:cNvSpPr/>
-          <p:nvPr/>
-        </p:nvSpPr>
-        <p:spPr>
-          <a:xfrm>
-            <a:off x="8858021" y="2724912"/>
-            <a:ext cx="2556434" cy="896112"/>
-          </a:xfrm>
-          <a:prstGeom prst="roundRect">
-            <a:avLst>
-              <a:gd name="adj" fmla="val 7143"/>
-            </a:avLst>
-          </a:prstGeom>
-          <a:solidFill>
-            <a:srgbClr val="FFFFFF"/>
-          </a:solidFill>
-          <a:ln w="9525">
-            <a:solidFill>
-              <a:srgbClr val="E2E1D6"/>
-            </a:solidFill>
-            <a:prstDash val="solid"/>
-          </a:ln>
-        </p:spPr>
-      </p:sp>
-      <p:sp>
-        <p:nvSpPr>
-          <p:cNvPr id="37" name="Shape 34"/>
-          <p:cNvSpPr/>
-          <p:nvPr/>
-        </p:nvSpPr>
-        <p:spPr>
-          <a:xfrm>
-            <a:off x="8976893" y="2843784"/>
-            <a:ext cx="237744" cy="237744"/>
-          </a:xfrm>
-          <a:prstGeom prst="ellipse">
-            <a:avLst/>
-          </a:prstGeom>
-          <a:solidFill>
-            <a:srgbClr val="E8722C"/>
-          </a:solidFill>
-          <a:ln/>
-        </p:spPr>
-      </p:sp>
-      <p:sp>
-        <p:nvSpPr>
-          <p:cNvPr id="38" name="Text 35"/>
-          <p:cNvSpPr txBox="1"/>
-          <p:nvPr/>
-        </p:nvSpPr>
-        <p:spPr>
-          <a:xfrm>
-            <a:off x="8976893" y="3127248"/>
-            <a:ext cx="2318690" cy="237744"/>
-          </a:xfrm>
-          <a:prstGeom prst="rect">
-            <a:avLst/>
-          </a:prstGeom>
-          <a:noFill/>
-          <a:ln/>
-        </p:spPr>
-        <p:txBody>
-          <a:bodyPr wrap="square" lIns="0" tIns="0" rIns="0" bIns="0" rtlCol="0" anchor="ctr"/>
-          <a:lstStyle/>
-          <a:p>
-            <a:pPr indent="0" marL="0">
-              <a:buNone/>
-            </a:pPr>
-            <a:r>
-              <a:rPr lang="en-US" sz="950" b="1" dirty="0">
-                <a:solidFill>
-                  <a:srgbClr val="0F1B2D"/>
-                </a:solidFill>
-              </a:rPr>
-              <a:t>Preparedness Checklists</a:t>
-            </a:r>
-            <a:endParaRPr lang="en-US" sz="950" dirty="0"/>
-          </a:p>
-        </p:txBody>
-      </p:sp>
-      <p:sp>
-        <p:nvSpPr>
-          <p:cNvPr id="39" name="Text 36"/>
-          <p:cNvSpPr txBox="1"/>
-          <p:nvPr/>
-        </p:nvSpPr>
-        <p:spPr>
-          <a:xfrm>
-            <a:off x="8976893" y="3364992"/>
-            <a:ext cx="2318690" cy="246888"/>
-          </a:xfrm>
-          <a:prstGeom prst="rect">
-            <a:avLst/>
-          </a:prstGeom>
-          <a:noFill/>
-          <a:ln/>
-        </p:spPr>
-        <p:txBody>
-          <a:bodyPr wrap="square" lIns="0" tIns="0" rIns="0" bIns="0" rtlCol="0" anchor="t"/>
-          <a:lstStyle/>
-          <a:p>
-            <a:pPr indent="0" marL="0">
-              <a:buNone/>
-            </a:pPr>
-            <a:r>
-              <a:rPr lang="en-US" sz="750" dirty="0">
-                <a:solidFill>
-                  <a:srgbClr val="6B7684"/>
-                </a:solidFill>
-              </a:rPr>
-              <a:t>Auto-generated per agency, ready before an event escalates</a:t>
-            </a:r>
-            <a:endParaRPr lang="en-US" sz="750" dirty="0"/>
-          </a:p>
-        </p:txBody>
-      </p:sp>
-      <p:sp>
-        <p:nvSpPr>
-          <p:cNvPr id="40" name="Shape 37"/>
-          <p:cNvSpPr/>
-          <p:nvPr/>
-        </p:nvSpPr>
-        <p:spPr>
-          <a:xfrm>
-            <a:off x="777240" y="3712464"/>
-            <a:ext cx="2556434" cy="896112"/>
-          </a:xfrm>
-          <a:prstGeom prst="roundRect">
-            <a:avLst>
-              <a:gd name="adj" fmla="val 7143"/>
-            </a:avLst>
-          </a:prstGeom>
-          <a:solidFill>
-            <a:srgbClr val="FFFFFF"/>
-          </a:solidFill>
-          <a:ln w="9525">
-            <a:solidFill>
-              <a:srgbClr val="E2E1D6"/>
-            </a:solidFill>
-            <a:prstDash val="solid"/>
-          </a:ln>
-        </p:spPr>
-      </p:sp>
-      <p:sp>
-        <p:nvSpPr>
-          <p:cNvPr id="41" name="Shape 38"/>
-          <p:cNvSpPr/>
-          <p:nvPr/>
-        </p:nvSpPr>
-        <p:spPr>
-          <a:xfrm>
-            <a:off x="896112" y="3831336"/>
-            <a:ext cx="237744" cy="237744"/>
-          </a:xfrm>
-          <a:prstGeom prst="ellipse">
-            <a:avLst/>
-          </a:prstGeom>
-          <a:solidFill>
-            <a:srgbClr val="E8722C"/>
-          </a:solidFill>
-          <a:ln/>
-        </p:spPr>
-      </p:sp>
-      <p:sp>
-        <p:nvSpPr>
-          <p:cNvPr id="42" name="Text 39"/>
-          <p:cNvSpPr txBox="1"/>
-          <p:nvPr/>
-        </p:nvSpPr>
-        <p:spPr>
-          <a:xfrm>
-            <a:off x="896112" y="4114800"/>
-            <a:ext cx="2318690" cy="237744"/>
-          </a:xfrm>
-          <a:prstGeom prst="rect">
-            <a:avLst/>
-          </a:prstGeom>
-          <a:noFill/>
-          <a:ln/>
-        </p:spPr>
-        <p:txBody>
-          <a:bodyPr wrap="square" lIns="0" tIns="0" rIns="0" bIns="0" rtlCol="0" anchor="ctr"/>
-          <a:lstStyle/>
-          <a:p>
-            <a:pPr indent="0" marL="0">
-              <a:buNone/>
-            </a:pPr>
-            <a:r>
-              <a:rPr lang="en-US" sz="950" b="1" dirty="0">
-                <a:solidFill>
-                  <a:srgbClr val="0F1B2D"/>
-                </a:solidFill>
-              </a:rPr>
-              <a:t>Agency Alert Drafting</a:t>
-            </a:r>
-            <a:endParaRPr lang="en-US" sz="950" dirty="0"/>
-          </a:p>
-        </p:txBody>
-      </p:sp>
-      <p:sp>
-        <p:nvSpPr>
-          <p:cNvPr id="43" name="Text 40"/>
-          <p:cNvSpPr txBox="1"/>
-          <p:nvPr/>
-        </p:nvSpPr>
-        <p:spPr>
-          <a:xfrm>
-            <a:off x="896112" y="4352544"/>
-            <a:ext cx="2318690" cy="246888"/>
-          </a:xfrm>
-          <a:prstGeom prst="rect">
-            <a:avLst/>
-          </a:prstGeom>
-          <a:noFill/>
-          <a:ln/>
-        </p:spPr>
-        <p:txBody>
-          <a:bodyPr wrap="square" lIns="0" tIns="0" rIns="0" bIns="0" rtlCol="0" anchor="t"/>
-          <a:lstStyle/>
-          <a:p>
-            <a:pPr indent="0" marL="0">
-              <a:buNone/>
-            </a:pPr>
-            <a:r>
-              <a:rPr lang="en-US" sz="750" dirty="0">
-                <a:solidFill>
-                  <a:srgbClr val="6B7684"/>
-                </a:solidFill>
-              </a:rPr>
-              <a:t>Automated first-draft alerts, ready for review and send</a:t>
-            </a:r>
-            <a:endParaRPr lang="en-US" sz="750" dirty="0"/>
-          </a:p>
-        </p:txBody>
-      </p:sp>
-      <p:sp>
-        <p:nvSpPr>
-          <p:cNvPr id="44" name="Shape 41"/>
-          <p:cNvSpPr/>
-          <p:nvPr/>
-        </p:nvSpPr>
-        <p:spPr>
-          <a:xfrm>
-            <a:off x="3470834" y="3712464"/>
-            <a:ext cx="2556434" cy="896112"/>
-          </a:xfrm>
-          <a:prstGeom prst="roundRect">
-            <a:avLst>
-              <a:gd name="adj" fmla="val 7143"/>
-            </a:avLst>
-          </a:prstGeom>
-          <a:solidFill>
-            <a:srgbClr val="FFFFFF"/>
-          </a:solidFill>
-          <a:ln w="9525">
-            <a:solidFill>
-              <a:srgbClr val="E2E1D6"/>
-            </a:solidFill>
-            <a:prstDash val="solid"/>
-          </a:ln>
-        </p:spPr>
-      </p:sp>
-      <p:sp>
-        <p:nvSpPr>
-          <p:cNvPr id="45" name="Shape 42"/>
-          <p:cNvSpPr/>
-          <p:nvPr/>
-        </p:nvSpPr>
-        <p:spPr>
-          <a:xfrm>
-            <a:off x="3589706" y="3831336"/>
-            <a:ext cx="237744" cy="237744"/>
-          </a:xfrm>
-          <a:prstGeom prst="ellipse">
-            <a:avLst/>
-          </a:prstGeom>
-          <a:solidFill>
-            <a:srgbClr val="5B6472"/>
-          </a:solidFill>
-          <a:ln/>
-        </p:spPr>
-      </p:sp>
-      <p:sp>
-        <p:nvSpPr>
-          <p:cNvPr id="46" name="Text 43"/>
-          <p:cNvSpPr txBox="1"/>
-          <p:nvPr/>
-        </p:nvSpPr>
-        <p:spPr>
-          <a:xfrm>
-            <a:off x="3589706" y="4114800"/>
-            <a:ext cx="2318690" cy="237744"/>
-          </a:xfrm>
-          <a:prstGeom prst="rect">
-            <a:avLst/>
-          </a:prstGeom>
-          <a:noFill/>
-          <a:ln/>
-        </p:spPr>
-        <p:txBody>
-          <a:bodyPr wrap="square" lIns="0" tIns="0" rIns="0" bIns="0" rtlCol="0" anchor="ctr"/>
-          <a:lstStyle/>
-          <a:p>
-            <a:pPr indent="0" marL="0">
-              <a:buNone/>
-            </a:pPr>
-            <a:r>
-              <a:rPr lang="en-US" sz="950" b="1" dirty="0">
-                <a:solidFill>
-                  <a:srgbClr val="0F1B2D"/>
-                </a:solidFill>
-              </a:rPr>
-              <a:t>Live Incident Dashboard</a:t>
-            </a:r>
-            <a:endParaRPr lang="en-US" sz="950" dirty="0"/>
-          </a:p>
-        </p:txBody>
-      </p:sp>
-      <p:sp>
-        <p:nvSpPr>
-          <p:cNvPr id="47" name="Text 44"/>
-          <p:cNvSpPr txBox="1"/>
-          <p:nvPr/>
-        </p:nvSpPr>
-        <p:spPr>
-          <a:xfrm>
-            <a:off x="3589706" y="4352544"/>
-            <a:ext cx="2318690" cy="246888"/>
-          </a:xfrm>
-          <a:prstGeom prst="rect">
-            <a:avLst/>
-          </a:prstGeom>
-          <a:noFill/>
-          <a:ln/>
-        </p:spPr>
-        <p:txBody>
-          <a:bodyPr wrap="square" lIns="0" tIns="0" rIns="0" bIns="0" rtlCol="0" anchor="t"/>
-          <a:lstStyle/>
-          <a:p>
-            <a:pPr indent="0" marL="0">
-              <a:buNone/>
-            </a:pPr>
-            <a:r>
-              <a:rPr lang="en-US" sz="750" dirty="0">
-                <a:solidFill>
-                  <a:srgbClr val="6B7684"/>
-                </a:solidFill>
-              </a:rPr>
-              <a:t>Multi-hazard map + detail panel, WebSocket-live</a:t>
-            </a:r>
-            <a:endParaRPr lang="en-US" sz="750" dirty="0"/>
-          </a:p>
-        </p:txBody>
-      </p:sp>
-      <p:sp>
-        <p:nvSpPr>
-          <p:cNvPr id="48" name="Shape 45"/>
-          <p:cNvSpPr/>
-          <p:nvPr/>
-        </p:nvSpPr>
-        <p:spPr>
-          <a:xfrm>
-            <a:off x="6164428" y="3712464"/>
-            <a:ext cx="2556434" cy="896112"/>
-          </a:xfrm>
-          <a:prstGeom prst="roundRect">
-            <a:avLst>
-              <a:gd name="adj" fmla="val 7143"/>
-            </a:avLst>
-          </a:prstGeom>
-          <a:solidFill>
-            <a:srgbClr val="FFFFFF"/>
-          </a:solidFill>
-          <a:ln w="9525">
-            <a:solidFill>
-              <a:srgbClr val="E2E1D6"/>
-            </a:solidFill>
-            <a:prstDash val="solid"/>
-          </a:ln>
-        </p:spPr>
-      </p:sp>
-      <p:sp>
-        <p:nvSpPr>
-          <p:cNvPr id="49" name="Shape 46"/>
-          <p:cNvSpPr/>
-          <p:nvPr/>
-        </p:nvSpPr>
-        <p:spPr>
-          <a:xfrm>
-            <a:off x="6283300" y="3831336"/>
-            <a:ext cx="237744" cy="237744"/>
-          </a:xfrm>
-          <a:prstGeom prst="ellipse">
-            <a:avLst/>
-          </a:prstGeom>
-          <a:solidFill>
-            <a:srgbClr val="5B6472"/>
-          </a:solidFill>
-          <a:ln/>
-        </p:spPr>
-      </p:sp>
-      <p:sp>
-        <p:nvSpPr>
-          <p:cNvPr id="50" name="Text 47"/>
-          <p:cNvSpPr txBox="1"/>
-          <p:nvPr/>
-        </p:nvSpPr>
-        <p:spPr>
-          <a:xfrm>
-            <a:off x="6283300" y="4114800"/>
-            <a:ext cx="2318690" cy="237744"/>
-          </a:xfrm>
-          <a:prstGeom prst="rect">
-            <a:avLst/>
-          </a:prstGeom>
-          <a:noFill/>
-          <a:ln/>
-        </p:spPr>
-        <p:txBody>
-          <a:bodyPr wrap="square" lIns="0" tIns="0" rIns="0" bIns="0" rtlCol="0" anchor="ctr"/>
-          <a:lstStyle/>
-          <a:p>
-            <a:pPr indent="0" marL="0">
-              <a:buNone/>
-            </a:pPr>
-            <a:r>
-              <a:rPr lang="en-US" sz="950" b="1" dirty="0">
-                <a:solidFill>
-                  <a:srgbClr val="0F1B2D"/>
-                </a:solidFill>
-              </a:rPr>
-              <a:t>Evacuation Routing</a:t>
-            </a:r>
-            <a:endParaRPr lang="en-US" sz="950" dirty="0"/>
-          </a:p>
-        </p:txBody>
-      </p:sp>
-      <p:sp>
-        <p:nvSpPr>
-          <p:cNvPr id="51" name="Text 48"/>
-          <p:cNvSpPr txBox="1"/>
-          <p:nvPr/>
-        </p:nvSpPr>
-        <p:spPr>
-          <a:xfrm>
-            <a:off x="6283300" y="4352544"/>
-            <a:ext cx="2318690" cy="246888"/>
-          </a:xfrm>
-          <a:prstGeom prst="rect">
-            <a:avLst/>
-          </a:prstGeom>
-          <a:noFill/>
-          <a:ln/>
-        </p:spPr>
-        <p:txBody>
-          <a:bodyPr wrap="square" lIns="0" tIns="0" rIns="0" bIns="0" rtlCol="0" anchor="t"/>
-          <a:lstStyle/>
-          <a:p>
-            <a:pPr indent="0" marL="0">
-              <a:buNone/>
-            </a:pPr>
-            <a:r>
-              <a:rPr lang="en-US" sz="750" dirty="0">
-                <a:solidFill>
-                  <a:srgbClr val="6B7684"/>
-                </a:solidFill>
-              </a:rPr>
-              <a:t>OSRM road-network routing with automatic geodesic fallback</a:t>
-            </a:r>
-            <a:endParaRPr lang="en-US" sz="750" dirty="0"/>
-          </a:p>
-        </p:txBody>
-      </p:sp>
-      <p:sp>
-        <p:nvSpPr>
-          <p:cNvPr id="52" name="Shape 49"/>
-          <p:cNvSpPr/>
-          <p:nvPr/>
-        </p:nvSpPr>
-        <p:spPr>
-          <a:xfrm>
-            <a:off x="8858021" y="3712464"/>
-            <a:ext cx="2556434" cy="896112"/>
-          </a:xfrm>
-          <a:prstGeom prst="roundRect">
-            <a:avLst>
-              <a:gd name="adj" fmla="val 7143"/>
-            </a:avLst>
-          </a:prstGeom>
-          <a:solidFill>
-            <a:srgbClr val="FFFFFF"/>
-          </a:solidFill>
-          <a:ln w="9525">
-            <a:solidFill>
-              <a:srgbClr val="E2E1D6"/>
-            </a:solidFill>
-            <a:prstDash val="solid"/>
-          </a:ln>
-        </p:spPr>
-      </p:sp>
-      <p:sp>
-        <p:nvSpPr>
-          <p:cNvPr id="53" name="Shape 50"/>
-          <p:cNvSpPr/>
-          <p:nvPr/>
-        </p:nvSpPr>
-        <p:spPr>
-          <a:xfrm>
-            <a:off x="8976893" y="3831336"/>
-            <a:ext cx="237744" cy="237744"/>
-          </a:xfrm>
-          <a:prstGeom prst="ellipse">
-            <a:avLst/>
-          </a:prstGeom>
-          <a:solidFill>
-            <a:srgbClr val="5B6472"/>
-          </a:solidFill>
-          <a:ln/>
-        </p:spPr>
-      </p:sp>
-      <p:sp>
-        <p:nvSpPr>
-          <p:cNvPr id="54" name="Text 51"/>
-          <p:cNvSpPr txBox="1"/>
-          <p:nvPr/>
-        </p:nvSpPr>
-        <p:spPr>
-          <a:xfrm>
-            <a:off x="8976893" y="4114800"/>
-            <a:ext cx="2318690" cy="237744"/>
-          </a:xfrm>
-          <a:prstGeom prst="rect">
-            <a:avLst/>
-          </a:prstGeom>
-          <a:noFill/>
-          <a:ln/>
-        </p:spPr>
-        <p:txBody>
-          <a:bodyPr wrap="square" lIns="0" tIns="0" rIns="0" bIns="0" rtlCol="0" anchor="ctr"/>
-          <a:lstStyle/>
-          <a:p>
-            <a:pPr indent="0" marL="0">
-              <a:buNone/>
-            </a:pPr>
-            <a:r>
-              <a:rPr lang="en-US" sz="950" b="1" dirty="0">
-                <a:solidFill>
-                  <a:srgbClr val="0F1B2D"/>
-                </a:solidFill>
-              </a:rPr>
-              <a:t>Audience-Tailored Alerts</a:t>
-            </a:r>
-            <a:endParaRPr lang="en-US" sz="950" dirty="0"/>
-          </a:p>
-        </p:txBody>
-      </p:sp>
-      <p:sp>
-        <p:nvSpPr>
-          <p:cNvPr id="55" name="Text 52"/>
-          <p:cNvSpPr txBox="1"/>
-          <p:nvPr/>
-        </p:nvSpPr>
-        <p:spPr>
-          <a:xfrm>
-            <a:off x="8976893" y="4352544"/>
-            <a:ext cx="2318690" cy="246888"/>
-          </a:xfrm>
-          <a:prstGeom prst="rect">
-            <a:avLst/>
-          </a:prstGeom>
-          <a:noFill/>
-          <a:ln/>
-        </p:spPr>
-        <p:txBody>
-          <a:bodyPr wrap="square" lIns="0" tIns="0" rIns="0" bIns="0" rtlCol="0" anchor="t"/>
-          <a:lstStyle/>
-          <a:p>
-            <a:pPr indent="0" marL="0">
-              <a:buNone/>
-            </a:pPr>
-            <a:r>
-              <a:rPr lang="en-US" sz="750" dirty="0">
-                <a:solidFill>
-                  <a:srgbClr val="6B7684"/>
-                </a:solidFill>
-              </a:rPr>
-              <a:t>Role-based email dispatch — farmers, hospitals, NGOs, municipal corps</a:t>
-            </a:r>
-            <a:endParaRPr lang="en-US" sz="750" dirty="0"/>
-          </a:p>
-        </p:txBody>
-      </p:sp>
-      <p:sp>
-        <p:nvSpPr>
-          <p:cNvPr id="56" name="Shape 53"/>
-          <p:cNvSpPr/>
-          <p:nvPr/>
-        </p:nvSpPr>
-        <p:spPr>
-          <a:xfrm>
-            <a:off x="777240" y="4700016"/>
-            <a:ext cx="2556434" cy="896112"/>
-          </a:xfrm>
-          <a:prstGeom prst="roundRect">
-            <a:avLst>
-              <a:gd name="adj" fmla="val 7143"/>
-            </a:avLst>
-          </a:prstGeom>
-          <a:solidFill>
-            <a:srgbClr val="FFFFFF"/>
-          </a:solidFill>
-          <a:ln w="9525">
-            <a:solidFill>
-              <a:srgbClr val="E2E1D6"/>
-            </a:solidFill>
-            <a:prstDash val="solid"/>
-          </a:ln>
-        </p:spPr>
-      </p:sp>
-      <p:sp>
-        <p:nvSpPr>
-          <p:cNvPr id="57" name="Shape 54"/>
-          <p:cNvSpPr/>
-          <p:nvPr/>
-        </p:nvSpPr>
-        <p:spPr>
-          <a:xfrm>
-            <a:off x="896112" y="4818888"/>
-            <a:ext cx="237744" cy="237744"/>
-          </a:xfrm>
-          <a:prstGeom prst="ellipse">
-            <a:avLst/>
-          </a:prstGeom>
-          <a:solidFill>
-            <a:srgbClr val="5B6472"/>
-          </a:solidFill>
-          <a:ln/>
-        </p:spPr>
-      </p:sp>
-      <p:sp>
-        <p:nvSpPr>
-          <p:cNvPr id="58" name="Text 55"/>
-          <p:cNvSpPr txBox="1"/>
-          <p:nvPr/>
-        </p:nvSpPr>
-        <p:spPr>
-          <a:xfrm>
-            <a:off x="896112" y="5102352"/>
-            <a:ext cx="2318690" cy="237744"/>
-          </a:xfrm>
-          <a:prstGeom prst="rect">
-            <a:avLst/>
-          </a:prstGeom>
-          <a:noFill/>
-          <a:ln/>
-        </p:spPr>
-        <p:txBody>
-          <a:bodyPr wrap="square" lIns="0" tIns="0" rIns="0" bIns="0" rtlCol="0" anchor="ctr"/>
-          <a:lstStyle/>
-          <a:p>
-            <a:pPr indent="0" marL="0">
-              <a:buNone/>
-            </a:pPr>
-            <a:r>
-              <a:rPr lang="en-US" sz="950" b="1" dirty="0">
-                <a:solidFill>
-                  <a:srgbClr val="0F1B2D"/>
-                </a:solidFill>
-              </a:rPr>
-              <a:t>Multi-Language UI</a:t>
-            </a:r>
-            <a:endParaRPr lang="en-US" sz="950" dirty="0"/>
-          </a:p>
-        </p:txBody>
-      </p:sp>
-      <p:sp>
-        <p:nvSpPr>
-          <p:cNvPr id="59" name="Text 56"/>
-          <p:cNvSpPr txBox="1"/>
-          <p:nvPr/>
-        </p:nvSpPr>
-        <p:spPr>
-          <a:xfrm>
-            <a:off x="896112" y="5340096"/>
-            <a:ext cx="2318690" cy="246888"/>
-          </a:xfrm>
-          <a:prstGeom prst="rect">
-            <a:avLst/>
-          </a:prstGeom>
-          <a:noFill/>
-          <a:ln/>
-        </p:spPr>
-        <p:txBody>
-          <a:bodyPr wrap="square" lIns="0" tIns="0" rIns="0" bIns="0" rtlCol="0" anchor="t"/>
-          <a:lstStyle/>
-          <a:p>
-            <a:pPr indent="0" marL="0">
-              <a:buNone/>
-            </a:pPr>
-            <a:r>
-              <a:rPr lang="en-US" sz="750" dirty="0">
-                <a:solidFill>
-                  <a:srgbClr val="6B7684"/>
-                </a:solidFill>
-              </a:rPr>
-              <a:t>vue-i18n across the dashboard, with interactive Mapbox GL mapping</a:t>
-            </a:r>
-            <a:endParaRPr lang="en-US" sz="750" dirty="0"/>
-          </a:p>
-        </p:txBody>
-      </p:sp>
-      <p:sp>
-        <p:nvSpPr>
-          <p:cNvPr id="60" name="Text 57"/>
+            <a:pPr marL="342900" indent="-342900">
+              <a:spcAft>
+                <a:spcPts val="800"/>
+              </a:spcAft>
+              <a:buSzPct val="100000"/>
+              <a:buChar char="✓"/>
+            </a:pPr>
+            <a:r>
+              <a:rPr lang="en-US" sz="1050" dirty="0">
+                <a:solidFill>
+                  <a:srgbClr val="3A4452"/>
+                </a:solidFill>
+              </a:rPr>
+              <a:t>Before/after satellite damage assessment</a:t>
+            </a:r>
+            <a:endParaRPr lang="en-US" sz="1050" dirty="0"/>
+          </a:p>
+          <a:p>
+            <a:pPr marL="342900" indent="-342900">
+              <a:spcAft>
+                <a:spcPts val="800"/>
+              </a:spcAft>
+              <a:buSzPct val="100000"/>
+              <a:buChar char="✓"/>
+            </a:pPr>
+            <a:r>
+              <a:rPr lang="en-US" sz="1050" dirty="0">
+                <a:solidFill>
+                  <a:srgbClr val="3A4452"/>
+                </a:solidFill>
+              </a:rPr>
+              <a:t>Recovery-milestone tracking once an incident stabilizes</a:t>
+            </a:r>
+            <a:endParaRPr lang="en-US" sz="1050" dirty="0"/>
+          </a:p>
+        </p:txBody>
+      </p:sp>
+      <p:sp>
+        <p:nvSpPr>
+          <p:cNvPr id="24" name="Text 21"/>
           <p:cNvSpPr txBox="1"/>
           <p:nvPr/>
         </p:nvSpPr>

</xml_diff>

<commit_message>
Add a Common Capabilities band to the Features slide
Source of Truth, multi-source ingestion, real-time WebSocket updates, and
multi-language UI aren't owned by one phase — Source of Truth runs across
Prepare and Respond (and is scoped for Predict/Recover), the rest run
platform-wide. Pulled them out of the phase columns into one shared band
below the 4-column grid instead of leaving them buried in a footer note or
attached to whichever phase happened to list them first.

Prepare and Respond columns are shorter now (6 and 7 items) since Source
of Truth moved out of both.

Co-Authored-By: Claude Sonnet 5 <noreply@anthropic.com>
Claude-Session: https://claude.ai/code/session_019qWxRvMCbpSwCqhEjV4xYF
</commit_message>
<xml_diff>
--- a/docs/PPT/TerraGrid_AI_Builder_Cup_Submission_copilot_terragrid.pptx
+++ b/docs/PPT/TerraGrid_AI_Builder_Cup_Submission_copilot_terragrid.pptx
@@ -16544,7 +16544,7 @@
         </p:nvSpPr>
         <p:spPr>
           <a:xfrm>
-            <a:off x="777240" y="1143000"/>
+            <a:off x="777240" y="1097280"/>
             <a:ext cx="10637215" cy="548640"/>
           </a:xfrm>
           <a:prstGeom prst="rect">
@@ -16561,7 +16561,7 @@
               <a:buNone/>
             </a:pPr>
             <a:r>
-              <a:rPr lang="en-US" sz="2000" b="1" dirty="0">
+              <a:rPr lang="en-US" sz="1900" b="1" dirty="0">
                 <a:solidFill>
                   <a:srgbClr val="0F1B2D"/>
                 </a:solidFill>
@@ -16571,7 +16571,7 @@
               </a:rPr>
               <a:t>Features Offered By The Solution — Across The 4-Phase Model</a:t>
             </a:r>
-            <a:endParaRPr lang="en-US" sz="2000" dirty="0"/>
+            <a:endParaRPr lang="en-US" sz="1900" dirty="0"/>
           </a:p>
         </p:txBody>
       </p:sp>
@@ -16583,8 +16583,8 @@
         </p:nvSpPr>
         <p:spPr>
           <a:xfrm>
-            <a:off x="777240" y="1600200"/>
-            <a:ext cx="2330265" cy="4297680"/>
+            <a:off x="777240" y="1508760"/>
+            <a:ext cx="2330265" cy="3749040"/>
           </a:xfrm>
           <a:prstGeom prst="roundRect">
             <a:avLst>
@@ -16610,7 +16610,7 @@
         </p:nvSpPr>
         <p:spPr>
           <a:xfrm>
-            <a:off x="905256" y="1719072"/>
+            <a:off x="905256" y="1627632"/>
             <a:ext cx="2074233" cy="274320"/>
           </a:xfrm>
           <a:prstGeom prst="rect">
@@ -16646,7 +16646,7 @@
         </p:nvSpPr>
         <p:spPr>
           <a:xfrm>
-            <a:off x="905256" y="1965960"/>
+            <a:off x="905256" y="1874520"/>
             <a:ext cx="2074233" cy="201168"/>
           </a:xfrm>
           <a:prstGeom prst="rect">
@@ -16682,8 +16682,8 @@
         </p:nvSpPr>
         <p:spPr>
           <a:xfrm>
-            <a:off x="905256" y="2258568"/>
-            <a:ext cx="2074233" cy="3063240"/>
+            <a:off x="905256" y="2167128"/>
+            <a:ext cx="2074233" cy="2514600"/>
           </a:xfrm>
           <a:prstGeom prst="rect">
             <a:avLst/>
@@ -16758,7 +16758,7 @@
         </p:nvSpPr>
         <p:spPr>
           <a:xfrm>
-            <a:off x="905256" y="5577840"/>
+            <a:off x="905256" y="4937760"/>
             <a:ext cx="2074233" cy="256032"/>
           </a:xfrm>
           <a:prstGeom prst="rect">
@@ -16794,7 +16794,7 @@
         </p:nvSpPr>
         <p:spPr>
           <a:xfrm>
-            <a:off x="3235521" y="1600200"/>
+            <a:off x="3235521" y="1508760"/>
             <a:ext cx="2796318" cy="50292"/>
           </a:xfrm>
           <a:prstGeom prst="rect">
@@ -16814,8 +16814,8 @@
         </p:nvSpPr>
         <p:spPr>
           <a:xfrm>
-            <a:off x="3235521" y="1650492"/>
-            <a:ext cx="2796318" cy="4247388"/>
+            <a:off x="3235521" y="1559052"/>
+            <a:ext cx="2796318" cy="3698748"/>
           </a:xfrm>
           <a:prstGeom prst="rect">
             <a:avLst/>
@@ -16834,7 +16834,7 @@
         </p:nvSpPr>
         <p:spPr>
           <a:xfrm>
-            <a:off x="3363537" y="1737360"/>
+            <a:off x="3363537" y="1645920"/>
             <a:ext cx="2540286" cy="274320"/>
           </a:xfrm>
           <a:prstGeom prst="rect">
@@ -16870,8 +16870,8 @@
         </p:nvSpPr>
         <p:spPr>
           <a:xfrm>
-            <a:off x="3363537" y="2057400"/>
-            <a:ext cx="2540286" cy="3703320"/>
+            <a:off x="3363537" y="1965960"/>
+            <a:ext cx="2540286" cy="3154680"/>
           </a:xfrm>
           <a:prstGeom prst="rect">
             <a:avLst/>
@@ -16990,6 +16990,104 @@
             </a:r>
             <a:endParaRPr lang="en-US" sz="830" dirty="0"/>
           </a:p>
+        </p:txBody>
+      </p:sp>
+      <p:sp>
+        <p:nvSpPr>
+          <p:cNvPr id="17" name="Shape 14"/>
+          <p:cNvSpPr/>
+          <p:nvPr/>
+        </p:nvSpPr>
+        <p:spPr>
+          <a:xfrm>
+            <a:off x="6159856" y="1508760"/>
+            <a:ext cx="2796318" cy="50292"/>
+          </a:xfrm>
+          <a:prstGeom prst="rect">
+            <a:avLst/>
+          </a:prstGeom>
+          <a:solidFill>
+            <a:srgbClr val="E8722C"/>
+          </a:solidFill>
+          <a:ln/>
+        </p:spPr>
+      </p:sp>
+      <p:sp>
+        <p:nvSpPr>
+          <p:cNvPr id="18" name="Shape 15"/>
+          <p:cNvSpPr/>
+          <p:nvPr/>
+        </p:nvSpPr>
+        <p:spPr>
+          <a:xfrm>
+            <a:off x="6159856" y="1559052"/>
+            <a:ext cx="2796318" cy="3698748"/>
+          </a:xfrm>
+          <a:prstGeom prst="rect">
+            <a:avLst/>
+          </a:prstGeom>
+          <a:solidFill>
+            <a:srgbClr val="FFFFFF"/>
+          </a:solidFill>
+          <a:ln/>
+        </p:spPr>
+      </p:sp>
+      <p:sp>
+        <p:nvSpPr>
+          <p:cNvPr id="19" name="Text 16"/>
+          <p:cNvSpPr txBox="1"/>
+          <p:nvPr/>
+        </p:nvSpPr>
+        <p:spPr>
+          <a:xfrm>
+            <a:off x="6287872" y="1645920"/>
+            <a:ext cx="2540286" cy="274320"/>
+          </a:xfrm>
+          <a:prstGeom prst="rect">
+            <a:avLst/>
+          </a:prstGeom>
+          <a:noFill/>
+          <a:ln/>
+        </p:spPr>
+        <p:txBody>
+          <a:bodyPr wrap="square" lIns="0" tIns="0" rIns="0" bIns="0" rtlCol="0" anchor="ctr"/>
+          <a:lstStyle/>
+          <a:p>
+            <a:pPr indent="0" marL="0">
+              <a:buNone/>
+            </a:pPr>
+            <a:r>
+              <a:rPr lang="en-US" sz="1350" b="1" dirty="0">
+                <a:solidFill>
+                  <a:srgbClr val="E8722C"/>
+                </a:solidFill>
+              </a:rPr>
+              <a:t>Respond</a:t>
+            </a:r>
+            <a:endParaRPr lang="en-US" sz="1350" dirty="0"/>
+          </a:p>
+        </p:txBody>
+      </p:sp>
+      <p:sp>
+        <p:nvSpPr>
+          <p:cNvPr id="20" name="Text 17"/>
+          <p:cNvSpPr txBox="1"/>
+          <p:nvPr/>
+        </p:nvSpPr>
+        <p:spPr>
+          <a:xfrm>
+            <a:off x="6287872" y="1965960"/>
+            <a:ext cx="2540286" cy="3154680"/>
+          </a:xfrm>
+          <a:prstGeom prst="rect">
+            <a:avLst/>
+          </a:prstGeom>
+          <a:noFill/>
+          <a:ln/>
+        </p:spPr>
+        <p:txBody>
+          <a:bodyPr wrap="square" lIns="0" tIns="0" rIns="0" bIns="0" rtlCol="0" anchor="t"/>
+          <a:lstStyle/>
           <a:p>
             <a:pPr marL="342900" indent="-342900">
               <a:spcAft>
@@ -17004,108 +17102,10 @@
                   <a:srgbClr val="3A4452"/>
                 </a:solidFill>
               </a:rPr>
-              <a:t>Source of Truth — forecast data-integrity audit</a:t>
+              <a:t>Interactive live incident map — Mapbox GL, evacuation zones</a:t>
             </a:r>
             <a:endParaRPr lang="en-US" sz="830" dirty="0"/>
           </a:p>
-        </p:txBody>
-      </p:sp>
-      <p:sp>
-        <p:nvSpPr>
-          <p:cNvPr id="17" name="Shape 14"/>
-          <p:cNvSpPr/>
-          <p:nvPr/>
-        </p:nvSpPr>
-        <p:spPr>
-          <a:xfrm>
-            <a:off x="6159856" y="1600200"/>
-            <a:ext cx="2796318" cy="50292"/>
-          </a:xfrm>
-          <a:prstGeom prst="rect">
-            <a:avLst/>
-          </a:prstGeom>
-          <a:solidFill>
-            <a:srgbClr val="E8722C"/>
-          </a:solidFill>
-          <a:ln/>
-        </p:spPr>
-      </p:sp>
-      <p:sp>
-        <p:nvSpPr>
-          <p:cNvPr id="18" name="Shape 15"/>
-          <p:cNvSpPr/>
-          <p:nvPr/>
-        </p:nvSpPr>
-        <p:spPr>
-          <a:xfrm>
-            <a:off x="6159856" y="1650492"/>
-            <a:ext cx="2796318" cy="4247388"/>
-          </a:xfrm>
-          <a:prstGeom prst="rect">
-            <a:avLst/>
-          </a:prstGeom>
-          <a:solidFill>
-            <a:srgbClr val="FFFFFF"/>
-          </a:solidFill>
-          <a:ln/>
-        </p:spPr>
-      </p:sp>
-      <p:sp>
-        <p:nvSpPr>
-          <p:cNvPr id="19" name="Text 16"/>
-          <p:cNvSpPr txBox="1"/>
-          <p:nvPr/>
-        </p:nvSpPr>
-        <p:spPr>
-          <a:xfrm>
-            <a:off x="6287872" y="1737360"/>
-            <a:ext cx="2540286" cy="274320"/>
-          </a:xfrm>
-          <a:prstGeom prst="rect">
-            <a:avLst/>
-          </a:prstGeom>
-          <a:noFill/>
-          <a:ln/>
-        </p:spPr>
-        <p:txBody>
-          <a:bodyPr wrap="square" lIns="0" tIns="0" rIns="0" bIns="0" rtlCol="0" anchor="ctr"/>
-          <a:lstStyle/>
-          <a:p>
-            <a:pPr indent="0" marL="0">
-              <a:buNone/>
-            </a:pPr>
-            <a:r>
-              <a:rPr lang="en-US" sz="1350" b="1" dirty="0">
-                <a:solidFill>
-                  <a:srgbClr val="E8722C"/>
-                </a:solidFill>
-              </a:rPr>
-              <a:t>Respond</a:t>
-            </a:r>
-            <a:endParaRPr lang="en-US" sz="1350" dirty="0"/>
-          </a:p>
-        </p:txBody>
-      </p:sp>
-      <p:sp>
-        <p:nvSpPr>
-          <p:cNvPr id="20" name="Text 17"/>
-          <p:cNvSpPr txBox="1"/>
-          <p:nvPr/>
-        </p:nvSpPr>
-        <p:spPr>
-          <a:xfrm>
-            <a:off x="6287872" y="2057400"/>
-            <a:ext cx="2540286" cy="3703320"/>
-          </a:xfrm>
-          <a:prstGeom prst="rect">
-            <a:avLst/>
-          </a:prstGeom>
-          <a:noFill/>
-          <a:ln/>
-        </p:spPr>
-        <p:txBody>
-          <a:bodyPr wrap="square" lIns="0" tIns="0" rIns="0" bIns="0" rtlCol="0" anchor="t"/>
-          <a:lstStyle/>
           <a:p>
             <a:pPr marL="342900" indent="-342900">
               <a:spcAft>
@@ -17120,7 +17120,7 @@
                   <a:srgbClr val="3A4452"/>
                 </a:solidFill>
               </a:rPr>
-              <a:t>Interactive live incident map — Mapbox GL, evacuation zones</a:t>
+              <a:t>Gemini 2.5 Flash decision support with confidence scoring</a:t>
             </a:r>
             <a:endParaRPr lang="en-US" sz="830" dirty="0"/>
           </a:p>
@@ -17138,7 +17138,7 @@
                   <a:srgbClr val="3A4452"/>
                 </a:solidFill>
               </a:rPr>
-              <a:t>Gemini 2.5 Flash decision support with confidence scoring</a:t>
+              <a:t>Deterministic cascade &amp; resource optimizer (Hamilton apportionment, not AI-guessed)</a:t>
             </a:r>
             <a:endParaRPr lang="en-US" sz="830" dirty="0"/>
           </a:p>
@@ -17156,7 +17156,7 @@
                   <a:srgbClr val="3A4452"/>
                 </a:solidFill>
               </a:rPr>
-              <a:t>Source of Truth — full incident data lineage, every AI output logged</a:t>
+              <a:t>Satellite image + Sentinel-1 SAR cross-validation</a:t>
             </a:r>
             <a:endParaRPr lang="en-US" sz="830" dirty="0"/>
           </a:p>
@@ -17174,7 +17174,7 @@
                   <a:srgbClr val="3A4452"/>
                 </a:solidFill>
               </a:rPr>
-              <a:t>Deterministic cascade &amp; resource optimizer (Hamilton apportionment, not AI-guessed)</a:t>
+              <a:t>Impact scoring — Hazard + Exposure + Vulnerability (0–100)</a:t>
             </a:r>
             <a:endParaRPr lang="en-US" sz="830" dirty="0"/>
           </a:p>
@@ -17192,7 +17192,7 @@
                   <a:srgbClr val="3A4452"/>
                 </a:solidFill>
               </a:rPr>
-              <a:t>Satellite image + Sentinel-1 SAR cross-validation</a:t>
+              <a:t>Phased response timeline — Immediate / Urgent / Sustained</a:t>
             </a:r>
             <a:endParaRPr lang="en-US" sz="830" dirty="0"/>
           </a:p>
@@ -17210,42 +17210,6 @@
                   <a:srgbClr val="3A4452"/>
                 </a:solidFill>
               </a:rPr>
-              <a:t>Impact scoring — Hazard + Exposure + Vulnerability (0–100)</a:t>
-            </a:r>
-            <a:endParaRPr lang="en-US" sz="830" dirty="0"/>
-          </a:p>
-          <a:p>
-            <a:pPr marL="342900" indent="-342900">
-              <a:spcAft>
-                <a:spcPts val="600"/>
-              </a:spcAft>
-              <a:buSzPct val="100000"/>
-              <a:buChar char="✓"/>
-            </a:pPr>
-            <a:r>
-              <a:rPr lang="en-US" sz="830" dirty="0">
-                <a:solidFill>
-                  <a:srgbClr val="3A4452"/>
-                </a:solidFill>
-              </a:rPr>
-              <a:t>Phased response timeline — Immediate / Urgent / Sustained</a:t>
-            </a:r>
-            <a:endParaRPr lang="en-US" sz="830" dirty="0"/>
-          </a:p>
-          <a:p>
-            <a:pPr marL="342900" indent="-342900">
-              <a:spcAft>
-                <a:spcPts val="600"/>
-              </a:spcAft>
-              <a:buSzPct val="100000"/>
-              <a:buChar char="✓"/>
-            </a:pPr>
-            <a:r>
-              <a:rPr lang="en-US" sz="830" dirty="0">
-                <a:solidFill>
-                  <a:srgbClr val="3A4452"/>
-                </a:solidFill>
-              </a:rPr>
               <a:t>Causal chain explanation flowchart</a:t>
             </a:r>
             <a:endParaRPr lang="en-US" sz="830" dirty="0"/>
@@ -17260,8 +17224,8 @@
         </p:nvSpPr>
         <p:spPr>
           <a:xfrm>
-            <a:off x="9084190" y="1600200"/>
-            <a:ext cx="2330265" cy="4297680"/>
+            <a:off x="9084190" y="1508760"/>
+            <a:ext cx="2330265" cy="3749040"/>
           </a:xfrm>
           <a:prstGeom prst="roundRect">
             <a:avLst>
@@ -17287,7 +17251,7 @@
         </p:nvSpPr>
         <p:spPr>
           <a:xfrm>
-            <a:off x="9212206" y="1719072"/>
+            <a:off x="9212206" y="1627632"/>
             <a:ext cx="2074233" cy="274320"/>
           </a:xfrm>
           <a:prstGeom prst="rect">
@@ -17323,7 +17287,7 @@
         </p:nvSpPr>
         <p:spPr>
           <a:xfrm>
-            <a:off x="9212206" y="1965960"/>
+            <a:off x="9212206" y="1874520"/>
             <a:ext cx="2074233" cy="201168"/>
           </a:xfrm>
           <a:prstGeom prst="rect">
@@ -17359,8 +17323,8 @@
         </p:nvSpPr>
         <p:spPr>
           <a:xfrm>
-            <a:off x="9212206" y="2258568"/>
-            <a:ext cx="2074233" cy="3063240"/>
+            <a:off x="9212206" y="2167128"/>
+            <a:ext cx="2074233" cy="2514600"/>
           </a:xfrm>
           <a:prstGeom prst="rect">
             <a:avLst/>
@@ -17435,7 +17399,7 @@
         </p:nvSpPr>
         <p:spPr>
           <a:xfrm>
-            <a:off x="9212206" y="5577840"/>
+            <a:off x="9212206" y="4937760"/>
             <a:ext cx="2074233" cy="256032"/>
           </a:xfrm>
           <a:prstGeom prst="rect">
@@ -17465,14 +17429,36 @@
       </p:sp>
       <p:sp>
         <p:nvSpPr>
-          <p:cNvPr id="26" name="Text 23"/>
-          <p:cNvSpPr txBox="1"/>
-          <p:nvPr/>
-        </p:nvSpPr>
-        <p:spPr>
-          <a:xfrm>
-            <a:off x="777240" y="5989320"/>
-            <a:ext cx="10637215" cy="384048"/>
+          <p:cNvPr id="26" name="Shape 23"/>
+          <p:cNvSpPr/>
+          <p:nvPr/>
+        </p:nvSpPr>
+        <p:spPr>
+          <a:xfrm>
+            <a:off x="777240" y="5376672"/>
+            <a:ext cx="10637215" cy="749808"/>
+          </a:xfrm>
+          <a:prstGeom prst="roundRect">
+            <a:avLst>
+              <a:gd name="adj" fmla="val 8537"/>
+            </a:avLst>
+          </a:prstGeom>
+          <a:solidFill>
+            <a:srgbClr val="0F1B2D"/>
+          </a:solidFill>
+          <a:ln/>
+        </p:spPr>
+      </p:sp>
+      <p:sp>
+        <p:nvSpPr>
+          <p:cNvPr id="27" name="Text 24"/>
+          <p:cNvSpPr txBox="1"/>
+          <p:nvPr/>
+        </p:nvSpPr>
+        <p:spPr>
+          <a:xfrm>
+            <a:off x="978408" y="5468112"/>
+            <a:ext cx="10234879" cy="219456"/>
           </a:xfrm>
           <a:prstGeom prst="rect">
             <a:avLst/>
@@ -17488,14 +17474,265 @@
               <a:buNone/>
             </a:pPr>
             <a:r>
-              <a:rPr lang="en-US" sz="880" i="1" dirty="0">
+              <a:rPr lang="en-US" sz="1050" b="1" spc="50" kern="0" dirty="0">
+                <a:solidFill>
+                  <a:srgbClr val="F3F4F2"/>
+                </a:solidFill>
+                <a:latin typeface="Calibri" pitchFamily="34" charset="0"/>
+                <a:ea typeface="Calibri" pitchFamily="34" charset="-122"/>
+                <a:cs typeface="Calibri" pitchFamily="34" charset="-120"/>
+              </a:rPr>
+              <a:t>COMMON CAPABILITIES — BUILT ONCE, RUNNING ACROSS EVERY PHASE</a:t>
+            </a:r>
+            <a:endParaRPr lang="en-US" sz="1050" dirty="0"/>
+          </a:p>
+        </p:txBody>
+      </p:sp>
+      <p:sp>
+        <p:nvSpPr>
+          <p:cNvPr id="28" name="Text 25"/>
+          <p:cNvSpPr txBox="1"/>
+          <p:nvPr/>
+        </p:nvSpPr>
+        <p:spPr>
+          <a:xfrm>
+            <a:off x="978408" y="5742432"/>
+            <a:ext cx="2421560" cy="347472"/>
+          </a:xfrm>
+          <a:prstGeom prst="rect">
+            <a:avLst/>
+          </a:prstGeom>
+          <a:noFill/>
+          <a:ln/>
+        </p:spPr>
+        <p:txBody>
+          <a:bodyPr wrap="square" lIns="0" tIns="0" rIns="0" bIns="0" rtlCol="0" anchor="t"/>
+          <a:lstStyle/>
+          <a:p>
+            <a:pPr indent="0" marL="0">
+              <a:buNone/>
+            </a:pPr>
+            <a:r>
+              <a:rPr lang="en-US" sz="900" b="1" dirty="0">
+                <a:solidFill>
+                  <a:srgbClr val="F3F4F2"/>
+                </a:solidFill>
+                <a:latin typeface="Calibri" pitchFamily="34" charset="0"/>
+                <a:ea typeface="Calibri" pitchFamily="34" charset="-122"/>
+                <a:cs typeface="Calibri" pitchFamily="34" charset="-120"/>
+              </a:rPr>
+              <a:t>Source of Truth — </a:t>
+            </a:r>
+            <a:pPr indent="0" marL="0">
+              <a:buNone/>
+            </a:pPr>
+            <a:r>
+              <a:rPr lang="en-US" sz="900" dirty="0">
+                <a:solidFill>
+                  <a:srgbClr val="E3E8EE"/>
+                </a:solidFill>
+                <a:latin typeface="Calibri" pitchFamily="34" charset="0"/>
+                <a:ea typeface="Calibri" pitchFamily="34" charset="-122"/>
+                <a:cs typeface="Calibri" pitchFamily="34" charset="-120"/>
+              </a:rPr>
+              <a:t>4-layer data lineage &amp; audit trail, live in Prepare + Respond, scoped for Predict + Recover</a:t>
+            </a:r>
+            <a:endParaRPr lang="en-US" sz="900" dirty="0"/>
+          </a:p>
+        </p:txBody>
+      </p:sp>
+      <p:sp>
+        <p:nvSpPr>
+          <p:cNvPr id="29" name="Text 26"/>
+          <p:cNvSpPr txBox="1"/>
+          <p:nvPr/>
+        </p:nvSpPr>
+        <p:spPr>
+          <a:xfrm>
+            <a:off x="3582848" y="5742432"/>
+            <a:ext cx="2421560" cy="347472"/>
+          </a:xfrm>
+          <a:prstGeom prst="rect">
+            <a:avLst/>
+          </a:prstGeom>
+          <a:noFill/>
+          <a:ln/>
+        </p:spPr>
+        <p:txBody>
+          <a:bodyPr wrap="square" lIns="0" tIns="0" rIns="0" bIns="0" rtlCol="0" anchor="t"/>
+          <a:lstStyle/>
+          <a:p>
+            <a:pPr indent="0" marL="0">
+              <a:buNone/>
+            </a:pPr>
+            <a:r>
+              <a:rPr lang="en-US" sz="900" b="1" dirty="0">
+                <a:solidFill>
+                  <a:srgbClr val="F3F4F2"/>
+                </a:solidFill>
+                <a:latin typeface="Calibri" pitchFamily="34" charset="0"/>
+                <a:ea typeface="Calibri" pitchFamily="34" charset="-122"/>
+                <a:cs typeface="Calibri" pitchFamily="34" charset="-120"/>
+              </a:rPr>
+              <a:t>Multi-source live ingestion — </a:t>
+            </a:r>
+            <a:pPr indent="0" marL="0">
+              <a:buNone/>
+            </a:pPr>
+            <a:r>
+              <a:rPr lang="en-US" sz="900" dirty="0">
+                <a:solidFill>
+                  <a:srgbClr val="E3E8EE"/>
+                </a:solidFill>
+                <a:latin typeface="Calibri" pitchFamily="34" charset="0"/>
+                <a:ea typeface="Calibri" pitchFamily="34" charset="-122"/>
+                <a:cs typeface="Calibri" pitchFamily="34" charset="-120"/>
+              </a:rPr>
+              <a:t>6 APIs (NASA EONET, USGS, NOAA, GDACS, OpenWeatherMap, OSM/Overpass)</a:t>
+            </a:r>
+            <a:endParaRPr lang="en-US" sz="900" dirty="0"/>
+          </a:p>
+        </p:txBody>
+      </p:sp>
+      <p:sp>
+        <p:nvSpPr>
+          <p:cNvPr id="30" name="Text 27"/>
+          <p:cNvSpPr txBox="1"/>
+          <p:nvPr/>
+        </p:nvSpPr>
+        <p:spPr>
+          <a:xfrm>
+            <a:off x="6187288" y="5742432"/>
+            <a:ext cx="2421560" cy="347472"/>
+          </a:xfrm>
+          <a:prstGeom prst="rect">
+            <a:avLst/>
+          </a:prstGeom>
+          <a:noFill/>
+          <a:ln/>
+        </p:spPr>
+        <p:txBody>
+          <a:bodyPr wrap="square" lIns="0" tIns="0" rIns="0" bIns="0" rtlCol="0" anchor="t"/>
+          <a:lstStyle/>
+          <a:p>
+            <a:pPr indent="0" marL="0">
+              <a:buNone/>
+            </a:pPr>
+            <a:r>
+              <a:rPr lang="en-US" sz="900" b="1" dirty="0">
+                <a:solidFill>
+                  <a:srgbClr val="F3F4F2"/>
+                </a:solidFill>
+                <a:latin typeface="Calibri" pitchFamily="34" charset="0"/>
+                <a:ea typeface="Calibri" pitchFamily="34" charset="-122"/>
+                <a:cs typeface="Calibri" pitchFamily="34" charset="-120"/>
+              </a:rPr>
+              <a:t>Real-time WebSocket updates — </a:t>
+            </a:r>
+            <a:pPr indent="0" marL="0">
+              <a:buNone/>
+            </a:pPr>
+            <a:r>
+              <a:rPr lang="en-US" sz="900" dirty="0">
+                <a:solidFill>
+                  <a:srgbClr val="E3E8EE"/>
+                </a:solidFill>
+                <a:latin typeface="Calibri" pitchFamily="34" charset="0"/>
+                <a:ea typeface="Calibri" pitchFamily="34" charset="-122"/>
+                <a:cs typeface="Calibri" pitchFamily="34" charset="-120"/>
+              </a:rPr>
+              <a:t>across the dashboard — no manual refresh</a:t>
+            </a:r>
+            <a:endParaRPr lang="en-US" sz="900" dirty="0"/>
+          </a:p>
+        </p:txBody>
+      </p:sp>
+      <p:sp>
+        <p:nvSpPr>
+          <p:cNvPr id="31" name="Text 28"/>
+          <p:cNvSpPr txBox="1"/>
+          <p:nvPr/>
+        </p:nvSpPr>
+        <p:spPr>
+          <a:xfrm>
+            <a:off x="8791727" y="5742432"/>
+            <a:ext cx="2421560" cy="347472"/>
+          </a:xfrm>
+          <a:prstGeom prst="rect">
+            <a:avLst/>
+          </a:prstGeom>
+          <a:noFill/>
+          <a:ln/>
+        </p:spPr>
+        <p:txBody>
+          <a:bodyPr wrap="square" lIns="0" tIns="0" rIns="0" bIns="0" rtlCol="0" anchor="t"/>
+          <a:lstStyle/>
+          <a:p>
+            <a:pPr indent="0" marL="0">
+              <a:buNone/>
+            </a:pPr>
+            <a:r>
+              <a:rPr lang="en-US" sz="900" b="1" dirty="0">
+                <a:solidFill>
+                  <a:srgbClr val="F3F4F2"/>
+                </a:solidFill>
+                <a:latin typeface="Calibri" pitchFamily="34" charset="0"/>
+                <a:ea typeface="Calibri" pitchFamily="34" charset="-122"/>
+                <a:cs typeface="Calibri" pitchFamily="34" charset="-120"/>
+              </a:rPr>
+              <a:t>Multi-language UI — </a:t>
+            </a:r>
+            <a:pPr indent="0" marL="0">
+              <a:buNone/>
+            </a:pPr>
+            <a:r>
+              <a:rPr lang="en-US" sz="900" dirty="0">
+                <a:solidFill>
+                  <a:srgbClr val="E3E8EE"/>
+                </a:solidFill>
+                <a:latin typeface="Calibri" pitchFamily="34" charset="0"/>
+                <a:ea typeface="Calibri" pitchFamily="34" charset="-122"/>
+                <a:cs typeface="Calibri" pitchFamily="34" charset="-120"/>
+              </a:rPr>
+              <a:t>vue-i18n across the full dashboard</a:t>
+            </a:r>
+            <a:endParaRPr lang="en-US" sz="900" dirty="0"/>
+          </a:p>
+        </p:txBody>
+      </p:sp>
+      <p:sp>
+        <p:nvSpPr>
+          <p:cNvPr id="32" name="Text 29"/>
+          <p:cNvSpPr txBox="1"/>
+          <p:nvPr/>
+        </p:nvSpPr>
+        <p:spPr>
+          <a:xfrm>
+            <a:off x="777240" y="6181344"/>
+            <a:ext cx="10637215" cy="182880"/>
+          </a:xfrm>
+          <a:prstGeom prst="rect">
+            <a:avLst/>
+          </a:prstGeom>
+          <a:noFill/>
+          <a:ln/>
+        </p:spPr>
+        <p:txBody>
+          <a:bodyPr wrap="square" lIns="0" tIns="0" rIns="0" bIns="0" rtlCol="0" anchor="ctr"/>
+          <a:lstStyle/>
+          <a:p>
+            <a:pPr indent="0" marL="0">
+              <a:buNone/>
+            </a:pPr>
+            <a:r>
+              <a:rPr lang="en-US" sz="830" i="1" dirty="0">
                 <a:solidFill>
                   <a:srgbClr val="8A8470"/>
                 </a:solidFill>
               </a:rPr>
-              <a:t>Also built and running across every phase, shown live in the demo rather than listed per phase: 6-API live data fusion, real-time WebSocket updates, multi-language UI (vue-i18n). Predict and Recover have no functionality built yet — only Prepare and Respond are shipped today.</a:t>
-            </a:r>
-            <a:endParaRPr lang="en-US" sz="880" dirty="0"/>
+              <a:t>Predict and Recover are part of the 4-phase design (see The 4-Phase Model) but have no functionality built yet — only Prepare and Respond are shipped today.</a:t>
+            </a:r>
+            <a:endParaRPr lang="en-US" sz="830" dirty="0"/>
           </a:p>
         </p:txBody>
       </p:sp>

</xml_diff>